<commit_message>
Updated figures for cholesterol calcium analysis
</commit_message>
<xml_diff>
--- a/Presentations/High Cholesterol Causes Bone Demineralization.pptx
+++ b/Presentations/High Cholesterol Causes Bone Demineralization.pptx
@@ -5,7 +5,7 @@
     <p:sldMasterId id="2147483648" r:id="rId1"/>
   </p:sldMasterIdLst>
   <p:notesMasterIdLst>
-    <p:notesMasterId r:id="rId21"/>
+    <p:notesMasterId r:id="rId28"/>
   </p:notesMasterIdLst>
   <p:sldIdLst>
     <p:sldId id="256" r:id="rId2"/>
@@ -22,11 +22,18 @@
     <p:sldId id="267" r:id="rId13"/>
     <p:sldId id="268" r:id="rId14"/>
     <p:sldId id="269" r:id="rId15"/>
-    <p:sldId id="272" r:id="rId16"/>
-    <p:sldId id="275" r:id="rId17"/>
-    <p:sldId id="274" r:id="rId18"/>
-    <p:sldId id="270" r:id="rId19"/>
-    <p:sldId id="265" r:id="rId20"/>
+    <p:sldId id="278" r:id="rId16"/>
+    <p:sldId id="272" r:id="rId17"/>
+    <p:sldId id="277" r:id="rId18"/>
+    <p:sldId id="276" r:id="rId19"/>
+    <p:sldId id="279" r:id="rId20"/>
+    <p:sldId id="281" r:id="rId21"/>
+    <p:sldId id="280" r:id="rId22"/>
+    <p:sldId id="275" r:id="rId23"/>
+    <p:sldId id="270" r:id="rId24"/>
+    <p:sldId id="282" r:id="rId25"/>
+    <p:sldId id="265" r:id="rId26"/>
+    <p:sldId id="283" r:id="rId27"/>
   </p:sldIdLst>
   <p:sldSz cx="12192000" cy="6858000"/>
   <p:notesSz cx="6858000" cy="9144000"/>
@@ -215,7 +222,7 @@
           <a:p>
             <a:fld id="{2108C933-9906-B84E-BA8B-4DB7027499CD}" type="datetimeFigureOut">
               <a:rPr lang="en-US" smtClean="0"/>
-              <a:t>11/26/25</a:t>
+              <a:t>12/4/25</a:t>
             </a:fld>
             <a:endParaRPr lang="en-US"/>
           </a:p>
@@ -528,13 +535,14 @@
           <a:p>
             <a:r>
               <a:rPr lang="en-US" dirty="0"/>
-              <a:t>If correlated pleiotropy is balanced, then the Egger’s intercept will be near zero</a:t>
-            </a:r>
-          </a:p>
-          <a:p>
-            <a:r>
-              <a:rPr lang="en-US" dirty="0"/>
-              <a:t>Directional uncorrelated pleiotropy shows up as </a:t>
+              <a:t>FE – all variants have the same effects (variance is sampling error)</a:t>
+            </a:r>
+            <a:br>
+              <a:rPr lang="en-US" dirty="0"/>
+            </a:br>
+            <a:r>
+              <a:rPr lang="en-US" dirty="0"/>
+              <a:t>MRE – variants have nonidentical errors</a:t>
             </a:r>
           </a:p>
         </p:txBody>
@@ -565,7 +573,139 @@
     </p:spTree>
     <p:extLst>
       <p:ext uri="{BB962C8B-B14F-4D97-AF65-F5344CB8AC3E}">
-        <p14:creationId xmlns:p14="http://schemas.microsoft.com/office/powerpoint/2010/main" val="602406993"/>
+        <p14:creationId xmlns:p14="http://schemas.microsoft.com/office/powerpoint/2010/main" val="979155775"/>
+      </p:ext>
+    </p:extLst>
+  </p:cSld>
+  <p:clrMapOvr>
+    <a:masterClrMapping/>
+  </p:clrMapOvr>
+</p:notes>
+</file>
+
+<file path=ppt/notesSlides/notesSlide2.xml><?xml version="1.0" encoding="utf-8"?>
+<p:notes xmlns:a="http://schemas.openxmlformats.org/drawingml/2006/main" xmlns:r="http://schemas.openxmlformats.org/officeDocument/2006/relationships" xmlns:p="http://schemas.openxmlformats.org/presentationml/2006/main">
+  <p:cSld>
+    <p:spTree>
+      <p:nvGrpSpPr>
+        <p:cNvPr id="1" name=""/>
+        <p:cNvGrpSpPr/>
+        <p:nvPr/>
+      </p:nvGrpSpPr>
+      <p:grpSpPr>
+        <a:xfrm>
+          <a:off x="0" y="0"/>
+          <a:ext cx="0" cy="0"/>
+          <a:chOff x="0" y="0"/>
+          <a:chExt cx="0" cy="0"/>
+        </a:xfrm>
+      </p:grpSpPr>
+      <p:sp>
+        <p:nvSpPr>
+          <p:cNvPr id="2" name="Slide Image Placeholder 1"/>
+          <p:cNvSpPr>
+            <a:spLocks noGrp="1" noRot="1" noChangeAspect="1"/>
+          </p:cNvSpPr>
+          <p:nvPr>
+            <p:ph type="sldImg"/>
+          </p:nvPr>
+        </p:nvSpPr>
+        <p:spPr/>
+      </p:sp>
+      <p:sp>
+        <p:nvSpPr>
+          <p:cNvPr id="3" name="Notes Placeholder 2"/>
+          <p:cNvSpPr>
+            <a:spLocks noGrp="1"/>
+          </p:cNvSpPr>
+          <p:nvPr>
+            <p:ph type="body" idx="1"/>
+          </p:nvPr>
+        </p:nvSpPr>
+        <p:spPr/>
+        <p:txBody>
+          <a:bodyPr/>
+          <a:lstStyle/>
+          <a:p>
+            <a:r>
+              <a:rPr lang="en-US" sz="1200" b="0" i="0" kern="1200" dirty="0" err="1">
+                <a:solidFill>
+                  <a:schemeClr val="tx1"/>
+                </a:solidFill>
+                <a:effectLst/>
+                <a:latin typeface="+mn-lt"/>
+                <a:ea typeface="+mn-ea"/>
+                <a:cs typeface="+mn-cs"/>
+              </a:rPr>
+              <a:t>GEnetic</a:t>
+            </a:r>
+            <a:r>
+              <a:rPr lang="en-US" sz="1200" b="0" i="0" kern="1200" dirty="0">
+                <a:solidFill>
+                  <a:schemeClr val="tx1"/>
+                </a:solidFill>
+                <a:effectLst/>
+                <a:latin typeface="+mn-lt"/>
+                <a:ea typeface="+mn-ea"/>
+                <a:cs typeface="+mn-cs"/>
+              </a:rPr>
+              <a:t> Factors for </a:t>
+            </a:r>
+            <a:r>
+              <a:rPr lang="en-US" sz="1200" b="0" i="0" kern="1200" dirty="0" err="1">
+                <a:solidFill>
+                  <a:schemeClr val="tx1"/>
+                </a:solidFill>
+                <a:effectLst/>
+                <a:latin typeface="+mn-lt"/>
+                <a:ea typeface="+mn-ea"/>
+                <a:cs typeface="+mn-cs"/>
+              </a:rPr>
+              <a:t>OSteoporosis</a:t>
+            </a:r>
+            <a:r>
+              <a:rPr lang="en-US" sz="1200" b="0" i="0" kern="1200" dirty="0">
+                <a:solidFill>
+                  <a:schemeClr val="tx1"/>
+                </a:solidFill>
+                <a:effectLst/>
+                <a:latin typeface="+mn-lt"/>
+                <a:ea typeface="+mn-ea"/>
+                <a:cs typeface="+mn-cs"/>
+              </a:rPr>
+              <a:t> Consortium</a:t>
+            </a:r>
+            <a:endParaRPr lang="en-US" dirty="0"/>
+          </a:p>
+        </p:txBody>
+      </p:sp>
+      <p:sp>
+        <p:nvSpPr>
+          <p:cNvPr id="4" name="Slide Number Placeholder 3"/>
+          <p:cNvSpPr>
+            <a:spLocks noGrp="1"/>
+          </p:cNvSpPr>
+          <p:nvPr>
+            <p:ph type="sldNum" sz="quarter" idx="5"/>
+          </p:nvPr>
+        </p:nvSpPr>
+        <p:spPr/>
+        <p:txBody>
+          <a:bodyPr/>
+          <a:lstStyle/>
+          <a:p>
+            <a:fld id="{BD421778-832C-8F47-85C4-75A399DBD491}" type="slidenum">
+              <a:rPr lang="en-US" smtClean="0"/>
+              <a:t>23</a:t>
+            </a:fld>
+            <a:endParaRPr lang="en-US"/>
+          </a:p>
+        </p:txBody>
+      </p:sp>
+    </p:spTree>
+    <p:extLst>
+      <p:ext uri="{BB962C8B-B14F-4D97-AF65-F5344CB8AC3E}">
+        <p14:creationId xmlns:p14="http://schemas.microsoft.com/office/powerpoint/2010/main" val="2932936442"/>
       </p:ext>
     </p:extLst>
   </p:cSld>
@@ -722,7 +862,7 @@
           <a:p>
             <a:fld id="{867AE478-D44E-FE42-B366-E8DE952D93E4}" type="datetimeFigureOut">
               <a:rPr lang="en-US" smtClean="0"/>
-              <a:t>11/26/25</a:t>
+              <a:t>12/4/25</a:t>
             </a:fld>
             <a:endParaRPr lang="en-US"/>
           </a:p>
@@ -920,7 +1060,7 @@
           <a:p>
             <a:fld id="{867AE478-D44E-FE42-B366-E8DE952D93E4}" type="datetimeFigureOut">
               <a:rPr lang="en-US" smtClean="0"/>
-              <a:t>11/26/25</a:t>
+              <a:t>12/4/25</a:t>
             </a:fld>
             <a:endParaRPr lang="en-US"/>
           </a:p>
@@ -1128,7 +1268,7 @@
           <a:p>
             <a:fld id="{867AE478-D44E-FE42-B366-E8DE952D93E4}" type="datetimeFigureOut">
               <a:rPr lang="en-US" smtClean="0"/>
-              <a:t>11/26/25</a:t>
+              <a:t>12/4/25</a:t>
             </a:fld>
             <a:endParaRPr lang="en-US"/>
           </a:p>
@@ -1326,7 +1466,7 @@
           <a:p>
             <a:fld id="{867AE478-D44E-FE42-B366-E8DE952D93E4}" type="datetimeFigureOut">
               <a:rPr lang="en-US" smtClean="0"/>
-              <a:t>11/26/25</a:t>
+              <a:t>12/4/25</a:t>
             </a:fld>
             <a:endParaRPr lang="en-US"/>
           </a:p>
@@ -1601,7 +1741,7 @@
           <a:p>
             <a:fld id="{867AE478-D44E-FE42-B366-E8DE952D93E4}" type="datetimeFigureOut">
               <a:rPr lang="en-US" smtClean="0"/>
-              <a:t>11/26/25</a:t>
+              <a:t>12/4/25</a:t>
             </a:fld>
             <a:endParaRPr lang="en-US"/>
           </a:p>
@@ -1866,7 +2006,7 @@
           <a:p>
             <a:fld id="{867AE478-D44E-FE42-B366-E8DE952D93E4}" type="datetimeFigureOut">
               <a:rPr lang="en-US" smtClean="0"/>
-              <a:t>11/26/25</a:t>
+              <a:t>12/4/25</a:t>
             </a:fld>
             <a:endParaRPr lang="en-US"/>
           </a:p>
@@ -2278,7 +2418,7 @@
           <a:p>
             <a:fld id="{867AE478-D44E-FE42-B366-E8DE952D93E4}" type="datetimeFigureOut">
               <a:rPr lang="en-US" smtClean="0"/>
-              <a:t>11/26/25</a:t>
+              <a:t>12/4/25</a:t>
             </a:fld>
             <a:endParaRPr lang="en-US"/>
           </a:p>
@@ -2419,7 +2559,7 @@
           <a:p>
             <a:fld id="{867AE478-D44E-FE42-B366-E8DE952D93E4}" type="datetimeFigureOut">
               <a:rPr lang="en-US" smtClean="0"/>
-              <a:t>11/26/25</a:t>
+              <a:t>12/4/25</a:t>
             </a:fld>
             <a:endParaRPr lang="en-US"/>
           </a:p>
@@ -2532,7 +2672,7 @@
           <a:p>
             <a:fld id="{867AE478-D44E-FE42-B366-E8DE952D93E4}" type="datetimeFigureOut">
               <a:rPr lang="en-US" smtClean="0"/>
-              <a:t>11/26/25</a:t>
+              <a:t>12/4/25</a:t>
             </a:fld>
             <a:endParaRPr lang="en-US"/>
           </a:p>
@@ -2843,7 +2983,7 @@
           <a:p>
             <a:fld id="{867AE478-D44E-FE42-B366-E8DE952D93E4}" type="datetimeFigureOut">
               <a:rPr lang="en-US" smtClean="0"/>
-              <a:t>11/26/25</a:t>
+              <a:t>12/4/25</a:t>
             </a:fld>
             <a:endParaRPr lang="en-US"/>
           </a:p>
@@ -3131,7 +3271,7 @@
           <a:p>
             <a:fld id="{867AE478-D44E-FE42-B366-E8DE952D93E4}" type="datetimeFigureOut">
               <a:rPr lang="en-US" smtClean="0"/>
-              <a:t>11/26/25</a:t>
+              <a:t>12/4/25</a:t>
             </a:fld>
             <a:endParaRPr lang="en-US"/>
           </a:p>
@@ -3372,7 +3512,7 @@
           <a:p>
             <a:fld id="{867AE478-D44E-FE42-B366-E8DE952D93E4}" type="datetimeFigureOut">
               <a:rPr lang="en-US" smtClean="0"/>
-              <a:t>11/26/25</a:t>
+              <a:t>12/4/25</a:t>
             </a:fld>
             <a:endParaRPr lang="en-US"/>
           </a:p>
@@ -4574,28 +4714,130 @@
           </a:p>
         </p:txBody>
       </p:sp>
-      <p:sp>
-        <p:nvSpPr>
-          <p:cNvPr id="3" name="Content Placeholder 2">
-            <a:extLst>
-              <a:ext uri="{FF2B5EF4-FFF2-40B4-BE49-F238E27FC236}">
-                <a16:creationId xmlns:a16="http://schemas.microsoft.com/office/drawing/2014/main" id="{E779DFA8-FC97-4B11-E482-56ADE7AAB4F1}"/>
-              </a:ext>
-            </a:extLst>
-          </p:cNvPr>
-          <p:cNvSpPr>
-            <a:spLocks noGrp="1"/>
-          </p:cNvSpPr>
+      <p:pic>
+        <p:nvPicPr>
+          <p:cNvPr id="3074" name="Picture 2" descr="Relationship of one-sample and two-sample Mendelian randomization: populations and samples.  In all examples, the green box represents the same underlying population from which samples are drawn; the black circles represent the samples and the text in these summarises the source of association of genetic instrument with exposure (βZX) and association of genetic instrument with outcome (βZY). In one-sample MR (A) where βZX and βZY are estimated within the same population, there may be over-fitting of the data because the predicted (by genetic IV) values of X are then used to predict Y in the same sample. In this study type, weak instrument bias will be expected to bias towards the confounded result. In one-sample MR, it is not necessary to have exposures measured on all sample participants. For expensive exposures, these could be measured in a subsample (B). The properties and sources of bias will be broadly similar to those in (A), where exposures are measured in all participants, but the likelihood of weak instrument bias may be greater. When βZX is obtained in a one-sample MR study but with external weights (i.e., the&#10;association magnitudes taken from a GWAS to which the sample being used for the MR did not contribute), as shown in (C), over-fitting of the data is minimised. Ideally, in two-sample MR, both samples are drawn from the same underlying population but there is no overlap of participants between the two samples, as shown in (D). In this situation, data will not be over-fitted and any weak instrument bias would be expected to bias towards the null. As GWAS get larger, and with more cohorts contributing to them, the potential for overlap between samples in summary data two-sample MR becomes increasingly likely, as shown in (E). The more overlap there is between the two samples, the more effects of over-fitting and weak instrument bias become similar to those seen in one-sample MR. In figure (F), the two samples are drawn from two different underlying populations. This might occur when using MR for testing developmental origins, when βZX is estimated in pregnant women and βZY is estimated in their offspring. In that situation, it is important to consider (and ideally test) whether the βZX association in pregnancy is the same as in non-pregnant females and males (i.e., as in the offspring sample). Similarly, when using aggregate data in two-sample MR and when the outcome of interest can only occur in one sex (e.g., cervical or prostate cancer), ideally one would want aggregate βZX estimates to be sex-specific. If that is not possible, then drawing on other external evidence to consider the extent to which βZX is likely to be similar in females and males is important.">
+            <a:extLst>
+              <a:ext uri="{FF2B5EF4-FFF2-40B4-BE49-F238E27FC236}">
+                <a16:creationId xmlns:a16="http://schemas.microsoft.com/office/drawing/2014/main" id="{3430BA37-3483-BC9B-DE27-525AEEBCA0EC}"/>
+              </a:ext>
+            </a:extLst>
+          </p:cNvPr>
+          <p:cNvPicPr>
+            <a:picLocks noGrp="1" noChangeAspect="1" noChangeArrowheads="1"/>
+          </p:cNvPicPr>
           <p:nvPr>
             <p:ph idx="1"/>
           </p:nvPr>
-        </p:nvSpPr>
-        <p:spPr/>
-        <p:txBody>
-          <a:bodyPr/>
-          <a:lstStyle/>
-          <a:p>
-            <a:endParaRPr lang="en-US"/>
+        </p:nvPicPr>
+        <p:blipFill>
+          <a:blip r:embed="rId2">
+            <a:extLst>
+              <a:ext uri="{28A0092B-C50C-407E-A947-70E740481C1C}">
+                <a14:useLocalDpi xmlns:a14="http://schemas.microsoft.com/office/drawing/2010/main" val="0"/>
+              </a:ext>
+            </a:extLst>
+          </a:blip>
+          <a:srcRect/>
+          <a:stretch>
+            <a:fillRect/>
+          </a:stretch>
+        </p:blipFill>
+        <p:spPr bwMode="auto">
+          <a:xfrm>
+            <a:off x="1915968" y="1331193"/>
+            <a:ext cx="7650942" cy="4996534"/>
+          </a:xfrm>
+          <a:prstGeom prst="rect">
+            <a:avLst/>
+          </a:prstGeom>
+          <a:noFill/>
+          <a:extLst>
+            <a:ext uri="{909E8E84-426E-40DD-AFC4-6F175D3DCCD1}">
+              <a14:hiddenFill xmlns:a14="http://schemas.microsoft.com/office/drawing/2010/main">
+                <a:solidFill>
+                  <a:srgbClr val="FFFFFF"/>
+                </a:solidFill>
+              </a14:hiddenFill>
+            </a:ext>
+          </a:extLst>
+        </p:spPr>
+      </p:pic>
+      <p:sp>
+        <p:nvSpPr>
+          <p:cNvPr id="4" name="TextBox 3">
+            <a:extLst>
+              <a:ext uri="{FF2B5EF4-FFF2-40B4-BE49-F238E27FC236}">
+                <a16:creationId xmlns:a16="http://schemas.microsoft.com/office/drawing/2014/main" id="{11E7A558-5026-5AB4-8B62-57EE725F9AC9}"/>
+              </a:ext>
+            </a:extLst>
+          </p:cNvPr>
+          <p:cNvSpPr txBox="1"/>
+          <p:nvPr/>
+        </p:nvSpPr>
+        <p:spPr>
+          <a:xfrm>
+            <a:off x="6206490" y="6488668"/>
+            <a:ext cx="6577792" cy="369332"/>
+          </a:xfrm>
+          <a:prstGeom prst="rect">
+            <a:avLst/>
+          </a:prstGeom>
+          <a:noFill/>
+        </p:spPr>
+        <p:txBody>
+          <a:bodyPr wrap="square" rtlCol="0">
+            <a:spAutoFit/>
+          </a:bodyPr>
+          <a:lstStyle/>
+          <a:p>
+            <a:r>
+              <a:rPr lang="en-US" dirty="0"/>
+              <a:t>https://</a:t>
+            </a:r>
+            <a:r>
+              <a:rPr lang="en-US" dirty="0" err="1"/>
+              <a:t>mr-dictionary.mrcieu.ac.uk</a:t>
+            </a:r>
+            <a:r>
+              <a:rPr lang="en-US" dirty="0"/>
+              <a:t>/term/non-overlapping/</a:t>
+            </a:r>
+          </a:p>
+        </p:txBody>
+      </p:sp>
+      <p:sp>
+        <p:nvSpPr>
+          <p:cNvPr id="5" name="TextBox 4">
+            <a:extLst>
+              <a:ext uri="{FF2B5EF4-FFF2-40B4-BE49-F238E27FC236}">
+                <a16:creationId xmlns:a16="http://schemas.microsoft.com/office/drawing/2014/main" id="{A2F5065C-7B33-118F-EB09-A89E402F5489}"/>
+              </a:ext>
+            </a:extLst>
+          </p:cNvPr>
+          <p:cNvSpPr txBox="1"/>
+          <p:nvPr/>
+        </p:nvSpPr>
+        <p:spPr>
+          <a:xfrm>
+            <a:off x="1237577" y="4526280"/>
+            <a:ext cx="678391" cy="369332"/>
+          </a:xfrm>
+          <a:prstGeom prst="rect">
+            <a:avLst/>
+          </a:prstGeom>
+          <a:noFill/>
+        </p:spPr>
+        <p:txBody>
+          <a:bodyPr wrap="none" rtlCol="0">
+            <a:spAutoFit/>
+          </a:bodyPr>
+          <a:lstStyle/>
+          <a:p>
+            <a:r>
+              <a:rPr lang="en-US" dirty="0"/>
+              <a:t>Ideal</a:t>
+            </a:r>
           </a:p>
         </p:txBody>
       </p:sp>
@@ -4817,7 +5059,7 @@
           <p:cNvPr id="2" name="Title 1">
             <a:extLst>
               <a:ext uri="{FF2B5EF4-FFF2-40B4-BE49-F238E27FC236}">
-                <a16:creationId xmlns:a16="http://schemas.microsoft.com/office/drawing/2014/main" id="{72183D56-43DA-4CC8-FFC2-1D421921BD38}"/>
+                <a16:creationId xmlns:a16="http://schemas.microsoft.com/office/drawing/2014/main" id="{2AE7B6D0-AA28-8C05-E15D-ABAA279BE942}"/>
               </a:ext>
             </a:extLst>
           </p:cNvPr>
@@ -4835,77 +5077,17 @@
           <a:p>
             <a:r>
               <a:rPr lang="en-US" dirty="0"/>
-              <a:t>Caveats</a:t>
-            </a:r>
-          </a:p>
-        </p:txBody>
-      </p:sp>
-      <p:sp>
-        <p:nvSpPr>
-          <p:cNvPr id="3" name="Content Placeholder 2">
-            <a:extLst>
-              <a:ext uri="{FF2B5EF4-FFF2-40B4-BE49-F238E27FC236}">
-                <a16:creationId xmlns:a16="http://schemas.microsoft.com/office/drawing/2014/main" id="{E02C07B5-6496-98F8-7F06-855842AA0183}"/>
-              </a:ext>
-            </a:extLst>
-          </p:cNvPr>
-          <p:cNvSpPr>
-            <a:spLocks noGrp="1"/>
-          </p:cNvSpPr>
-          <p:nvPr>
-            <p:ph sz="half" idx="1"/>
-          </p:nvPr>
-        </p:nvSpPr>
-        <p:spPr/>
-        <p:txBody>
-          <a:bodyPr/>
-          <a:lstStyle/>
-          <a:p>
-            <a:r>
-              <a:rPr lang="en-US" dirty="0"/>
-              <a:t>Weak instrument bias</a:t>
-            </a:r>
-          </a:p>
-          <a:p>
-            <a:r>
-              <a:rPr lang="en-US" dirty="0"/>
-              <a:t>Heterogeneity</a:t>
-            </a:r>
-          </a:p>
-          <a:p>
-            <a:r>
-              <a:rPr lang="en-US" dirty="0"/>
-              <a:t>Horizontal Pleiotropy</a:t>
-            </a:r>
-          </a:p>
-          <a:p>
-            <a:pPr lvl="1"/>
-            <a:r>
-              <a:rPr lang="en-US" dirty="0"/>
-              <a:t>Correlated</a:t>
-            </a:r>
-          </a:p>
-          <a:p>
-            <a:pPr lvl="1"/>
-            <a:r>
-              <a:rPr lang="en-US" dirty="0"/>
-              <a:t>Uncorrelated</a:t>
-            </a:r>
-          </a:p>
-          <a:p>
-            <a:r>
-              <a:rPr lang="en-US" dirty="0"/>
-              <a:t>Association Driven by a Small Number of Influential SNPs</a:t>
+              <a:t>Validation of Method</a:t>
             </a:r>
           </a:p>
         </p:txBody>
       </p:sp>
       <p:pic>
         <p:nvPicPr>
-          <p:cNvPr id="5" name="Content Placeholder 4">
-            <a:extLst>
-              <a:ext uri="{FF2B5EF4-FFF2-40B4-BE49-F238E27FC236}">
-                <a16:creationId xmlns:a16="http://schemas.microsoft.com/office/drawing/2014/main" id="{B7DBE089-DDD7-AEB2-3FAA-4A5A1D81F867}"/>
+          <p:cNvPr id="6" name="Content Placeholder 5">
+            <a:extLst>
+              <a:ext uri="{FF2B5EF4-FFF2-40B4-BE49-F238E27FC236}">
+                <a16:creationId xmlns:a16="http://schemas.microsoft.com/office/drawing/2014/main" id="{7CBB92C4-AEE1-FF12-5C2D-78B8A019FFA8}"/>
               </a:ext>
             </a:extLst>
           </p:cNvPr>
@@ -4913,7 +5095,7 @@
             <a:picLocks noGrp="1" noChangeAspect="1"/>
           </p:cNvPicPr>
           <p:nvPr>
-            <p:ph sz="half" idx="2"/>
+            <p:ph sz="half" idx="1"/>
           </p:nvPr>
         </p:nvPicPr>
         <p:blipFill>
@@ -4924,18 +5106,107 @@
         </p:blipFill>
         <p:spPr>
           <a:xfrm>
-            <a:off x="6470650" y="2312194"/>
-            <a:ext cx="4584700" cy="3378200"/>
+            <a:off x="838200" y="2150723"/>
+            <a:ext cx="5181600" cy="3701142"/>
           </a:xfrm>
-          <a:prstGeom prst="rect">
-            <a:avLst/>
-          </a:prstGeom>
         </p:spPr>
       </p:pic>
+      <p:sp>
+        <p:nvSpPr>
+          <p:cNvPr id="4" name="Content Placeholder 3">
+            <a:extLst>
+              <a:ext uri="{FF2B5EF4-FFF2-40B4-BE49-F238E27FC236}">
+                <a16:creationId xmlns:a16="http://schemas.microsoft.com/office/drawing/2014/main" id="{C4C1D350-38E0-D65A-30F4-CCC15088290A}"/>
+              </a:ext>
+            </a:extLst>
+          </p:cNvPr>
+          <p:cNvSpPr>
+            <a:spLocks noGrp="1"/>
+          </p:cNvSpPr>
+          <p:nvPr>
+            <p:ph sz="half" idx="2"/>
+          </p:nvPr>
+        </p:nvSpPr>
+        <p:spPr/>
+        <p:txBody>
+          <a:bodyPr>
+            <a:normAutofit lnSpcReduction="10000"/>
+          </a:bodyPr>
+          <a:lstStyle/>
+          <a:p>
+            <a:r>
+              <a:rPr lang="en-US" dirty="0"/>
+              <a:t>Exposure</a:t>
+            </a:r>
+          </a:p>
+          <a:p>
+            <a:pPr lvl="1"/>
+            <a:r>
+              <a:rPr lang="en-US" dirty="0"/>
+              <a:t>Calcium SNPs (UKBB)</a:t>
+            </a:r>
+          </a:p>
+          <a:p>
+            <a:r>
+              <a:rPr lang="en-US" dirty="0"/>
+              <a:t>Outcome</a:t>
+            </a:r>
+          </a:p>
+          <a:p>
+            <a:pPr lvl="1"/>
+            <a:r>
+              <a:rPr lang="en-US" dirty="0"/>
+              <a:t>Calcium SNPs (MGI/</a:t>
+            </a:r>
+            <a:r>
+              <a:rPr lang="en-US" dirty="0" err="1"/>
+              <a:t>BioVU</a:t>
+            </a:r>
+            <a:r>
+              <a:rPr lang="en-US" dirty="0"/>
+              <a:t>)</a:t>
+            </a:r>
+          </a:p>
+          <a:p>
+            <a:r>
+              <a:rPr lang="en-US" dirty="0"/>
+              <a:t>Results</a:t>
+            </a:r>
+          </a:p>
+          <a:p>
+            <a:pPr lvl="1"/>
+            <a:r>
+              <a:rPr lang="en-US" dirty="0"/>
+              <a:t>Slope = 0.54 +/-  0.02</a:t>
+            </a:r>
+          </a:p>
+          <a:p>
+            <a:pPr lvl="1"/>
+            <a:r>
+              <a:rPr lang="en-US" dirty="0"/>
+              <a:t>SD for calcium is ~0.5</a:t>
+            </a:r>
+          </a:p>
+          <a:p>
+            <a:pPr lvl="1"/>
+            <a:r>
+              <a:rPr lang="en-US" dirty="0"/>
+              <a:t>1SD increase in genetically predicted calcium is associated with 1SD increase in calcium</a:t>
+            </a:r>
+          </a:p>
+          <a:p>
+            <a:pPr lvl="1"/>
+            <a:r>
+              <a:rPr lang="en-US" dirty="0"/>
+              <a:t>P&lt;0.0001</a:t>
+            </a:r>
+          </a:p>
+        </p:txBody>
+      </p:sp>
     </p:spTree>
     <p:extLst>
       <p:ext uri="{BB962C8B-B14F-4D97-AF65-F5344CB8AC3E}">
-        <p14:creationId xmlns:p14="http://schemas.microsoft.com/office/powerpoint/2010/main" val="2193163252"/>
+        <p14:creationId xmlns:p14="http://schemas.microsoft.com/office/powerpoint/2010/main" val="2437068361"/>
       </p:ext>
     </p:extLst>
   </p:cSld>
@@ -4967,7 +5238,7 @@
           <p:cNvPr id="2" name="Title 1">
             <a:extLst>
               <a:ext uri="{FF2B5EF4-FFF2-40B4-BE49-F238E27FC236}">
-                <a16:creationId xmlns:a16="http://schemas.microsoft.com/office/drawing/2014/main" id="{C91A23B5-01D2-030E-F22A-F2F00E1A5D77}"/>
+                <a16:creationId xmlns:a16="http://schemas.microsoft.com/office/drawing/2014/main" id="{72183D56-43DA-4CC8-FFC2-1D421921BD38}"/>
               </a:ext>
             </a:extLst>
           </p:cNvPr>
@@ -4983,7 +5254,10 @@
           <a:bodyPr/>
           <a:lstStyle/>
           <a:p>
-            <a:endParaRPr lang="en-US"/>
+            <a:r>
+              <a:rPr lang="en-US" dirty="0"/>
+              <a:t>Some Caveats with the Methods Used</a:t>
+            </a:r>
           </a:p>
         </p:txBody>
       </p:sp>
@@ -4992,7 +5266,7 @@
           <p:cNvPr id="3" name="Content Placeholder 2">
             <a:extLst>
               <a:ext uri="{FF2B5EF4-FFF2-40B4-BE49-F238E27FC236}">
-                <a16:creationId xmlns:a16="http://schemas.microsoft.com/office/drawing/2014/main" id="{EC1A4C40-E8C0-89BC-8143-C028F0F334A0}"/>
+                <a16:creationId xmlns:a16="http://schemas.microsoft.com/office/drawing/2014/main" id="{E02C07B5-6496-98F8-7F06-855842AA0183}"/>
               </a:ext>
             </a:extLst>
           </p:cNvPr>
@@ -5008,39 +5282,137 @@
           <a:bodyPr/>
           <a:lstStyle/>
           <a:p>
-            <a:endParaRPr lang="en-US"/>
-          </a:p>
-        </p:txBody>
-      </p:sp>
-      <p:sp>
-        <p:nvSpPr>
-          <p:cNvPr id="4" name="Content Placeholder 3">
-            <a:extLst>
-              <a:ext uri="{FF2B5EF4-FFF2-40B4-BE49-F238E27FC236}">
-                <a16:creationId xmlns:a16="http://schemas.microsoft.com/office/drawing/2014/main" id="{D3981B90-477F-FF78-D87E-707DA470F12E}"/>
-              </a:ext>
-            </a:extLst>
-          </p:cNvPr>
-          <p:cNvSpPr>
-            <a:spLocks noGrp="1"/>
-          </p:cNvSpPr>
+            <a:r>
+              <a:rPr lang="en-US" dirty="0"/>
+              <a:t>Weak instrument bias</a:t>
+            </a:r>
+          </a:p>
+          <a:p>
+            <a:r>
+              <a:rPr lang="en-US" dirty="0"/>
+              <a:t>Heterogeneity</a:t>
+            </a:r>
+          </a:p>
+          <a:p>
+            <a:r>
+              <a:rPr lang="en-US" dirty="0"/>
+              <a:t>Horizontal Pleiotropy</a:t>
+            </a:r>
+          </a:p>
+          <a:p>
+            <a:pPr lvl="1"/>
+            <a:r>
+              <a:rPr lang="en-US" dirty="0"/>
+              <a:t>Correlated</a:t>
+            </a:r>
+          </a:p>
+          <a:p>
+            <a:pPr lvl="1"/>
+            <a:r>
+              <a:rPr lang="en-US" dirty="0"/>
+              <a:t>Uncorrelated</a:t>
+            </a:r>
+          </a:p>
+          <a:p>
+            <a:r>
+              <a:rPr lang="en-US" dirty="0"/>
+              <a:t>Association Driven by a Small Number of Influential SNPs</a:t>
+            </a:r>
+          </a:p>
+        </p:txBody>
+      </p:sp>
+      <p:pic>
+        <p:nvPicPr>
+          <p:cNvPr id="5" name="Content Placeholder 4">
+            <a:extLst>
+              <a:ext uri="{FF2B5EF4-FFF2-40B4-BE49-F238E27FC236}">
+                <a16:creationId xmlns:a16="http://schemas.microsoft.com/office/drawing/2014/main" id="{B7DBE089-DDD7-AEB2-3FAA-4A5A1D81F867}"/>
+              </a:ext>
+            </a:extLst>
+          </p:cNvPr>
+          <p:cNvPicPr>
+            <a:picLocks noGrp="1" noChangeAspect="1"/>
+          </p:cNvPicPr>
           <p:nvPr>
             <p:ph sz="half" idx="2"/>
           </p:nvPr>
-        </p:nvSpPr>
-        <p:spPr/>
-        <p:txBody>
-          <a:bodyPr/>
-          <a:lstStyle/>
-          <a:p>
-            <a:endParaRPr lang="en-US"/>
+        </p:nvPicPr>
+        <p:blipFill>
+          <a:blip r:embed="rId2"/>
+          <a:stretch>
+            <a:fillRect/>
+          </a:stretch>
+        </p:blipFill>
+        <p:spPr>
+          <a:xfrm>
+            <a:off x="6470650" y="2312194"/>
+            <a:ext cx="4584700" cy="3378200"/>
+          </a:xfrm>
+          <a:prstGeom prst="rect">
+            <a:avLst/>
+          </a:prstGeom>
+        </p:spPr>
+      </p:pic>
+      <p:sp>
+        <p:nvSpPr>
+          <p:cNvPr id="6" name="TextBox 5">
+            <a:extLst>
+              <a:ext uri="{FF2B5EF4-FFF2-40B4-BE49-F238E27FC236}">
+                <a16:creationId xmlns:a16="http://schemas.microsoft.com/office/drawing/2014/main" id="{17E120DE-E303-BFFE-F9DD-0CBD90297966}"/>
+              </a:ext>
+            </a:extLst>
+          </p:cNvPr>
+          <p:cNvSpPr txBox="1"/>
+          <p:nvPr/>
+        </p:nvSpPr>
+        <p:spPr>
+          <a:xfrm>
+            <a:off x="6470650" y="5690394"/>
+            <a:ext cx="5721350" cy="1384995"/>
+          </a:xfrm>
+          <a:prstGeom prst="rect">
+            <a:avLst/>
+          </a:prstGeom>
+          <a:noFill/>
+        </p:spPr>
+        <p:txBody>
+          <a:bodyPr wrap="square" rtlCol="0">
+            <a:spAutoFit/>
+          </a:bodyPr>
+          <a:lstStyle/>
+          <a:p>
+            <a:r>
+              <a:rPr lang="en-US" sz="1400" dirty="0"/>
+              <a:t>Morrison, Jean, Nicholas Knoblauch, Joseph H. Marcus, Matthew Stephens, and Xin He. “Mendelian Randomization Accounting for Correlated and Uncorrelated Pleiotropic Effects Using Genome-Wide Summary Statistics.” </a:t>
+            </a:r>
+            <a:r>
+              <a:rPr lang="en-US" sz="1400" i="1" dirty="0"/>
+              <a:t>Nature Genetics</a:t>
+            </a:r>
+            <a:r>
+              <a:rPr lang="en-US" sz="1400" dirty="0"/>
+              <a:t> 52, no. 7 (2020): 740–47. </a:t>
+            </a:r>
+            <a:r>
+              <a:rPr lang="en-US" sz="1400" dirty="0">
+                <a:hlinkClick r:id="rId3"/>
+              </a:rPr>
+              <a:t>https://doi.org/10.1038/s41588-020-0631-4</a:t>
+            </a:r>
+            <a:r>
+              <a:rPr lang="en-US" sz="1400" dirty="0"/>
+              <a:t>.</a:t>
+            </a:r>
+          </a:p>
+          <a:p>
+            <a:endParaRPr lang="en-US" sz="1400" dirty="0"/>
           </a:p>
         </p:txBody>
       </p:sp>
     </p:spTree>
     <p:extLst>
       <p:ext uri="{BB962C8B-B14F-4D97-AF65-F5344CB8AC3E}">
-        <p14:creationId xmlns:p14="http://schemas.microsoft.com/office/powerpoint/2010/main" val="1252783467"/>
+        <p14:creationId xmlns:p14="http://schemas.microsoft.com/office/powerpoint/2010/main" val="2193163252"/>
       </p:ext>
     </p:extLst>
   </p:cSld>
@@ -5072,7 +5444,7 @@
           <p:cNvPr id="2" name="Title 1">
             <a:extLst>
               <a:ext uri="{FF2B5EF4-FFF2-40B4-BE49-F238E27FC236}">
-                <a16:creationId xmlns:a16="http://schemas.microsoft.com/office/drawing/2014/main" id="{8531E8F5-1F83-E1B7-9AA0-BB910048B01C}"/>
+                <a16:creationId xmlns:a16="http://schemas.microsoft.com/office/drawing/2014/main" id="{8205255B-ACD0-15D7-D8B5-01ADCE41A2F8}"/>
               </a:ext>
             </a:extLst>
           </p:cNvPr>
@@ -5090,310 +5462,105 @@
           <a:p>
             <a:r>
               <a:rPr lang="en-US" dirty="0"/>
-              <a:t>Correlated and Uncorrelated Pleiotropy</a:t>
-            </a:r>
-          </a:p>
-        </p:txBody>
-      </p:sp>
-      <p:pic>
-        <p:nvPicPr>
-          <p:cNvPr id="2050" name="Picture 2">
-            <a:extLst>
-              <a:ext uri="{FF2B5EF4-FFF2-40B4-BE49-F238E27FC236}">
-                <a16:creationId xmlns:a16="http://schemas.microsoft.com/office/drawing/2014/main" id="{40F1E3F6-AEEB-F0B5-AC1F-D007401AC590}"/>
-              </a:ext>
-            </a:extLst>
-          </p:cNvPr>
-          <p:cNvPicPr>
-            <a:picLocks noChangeAspect="1" noChangeArrowheads="1"/>
-          </p:cNvPicPr>
-          <p:nvPr/>
-        </p:nvPicPr>
-        <p:blipFill>
-          <a:blip r:embed="rId3">
-            <a:extLst>
-              <a:ext uri="{28A0092B-C50C-407E-A947-70E740481C1C}">
-                <a14:useLocalDpi xmlns:a14="http://schemas.microsoft.com/office/drawing/2010/main" val="0"/>
-              </a:ext>
-            </a:extLst>
-          </a:blip>
-          <a:srcRect/>
-          <a:stretch>
-            <a:fillRect/>
-          </a:stretch>
-        </p:blipFill>
-        <p:spPr bwMode="auto">
-          <a:xfrm>
-            <a:off x="3338368" y="2030845"/>
-            <a:ext cx="4406900" cy="1244600"/>
-          </a:xfrm>
-          <a:prstGeom prst="rect">
-            <a:avLst/>
-          </a:prstGeom>
-          <a:noFill/>
-          <a:extLst>
-            <a:ext uri="{909E8E84-426E-40DD-AFC4-6F175D3DCCD1}">
-              <a14:hiddenFill xmlns:a14="http://schemas.microsoft.com/office/drawing/2010/main">
-                <a:solidFill>
-                  <a:srgbClr val="FFFFFF"/>
-                </a:solidFill>
-              </a14:hiddenFill>
-            </a:ext>
-          </a:extLst>
-        </p:spPr>
-      </p:pic>
-      <p:pic>
-        <p:nvPicPr>
-          <p:cNvPr id="8" name="Picture 7">
-            <a:extLst>
-              <a:ext uri="{FF2B5EF4-FFF2-40B4-BE49-F238E27FC236}">
-                <a16:creationId xmlns:a16="http://schemas.microsoft.com/office/drawing/2014/main" id="{4B5B5AD9-8FAA-DC96-06B8-D55A306EEA78}"/>
-              </a:ext>
-            </a:extLst>
-          </p:cNvPr>
-          <p:cNvPicPr>
-            <a:picLocks noChangeAspect="1"/>
-          </p:cNvPicPr>
-          <p:nvPr/>
-        </p:nvPicPr>
-        <p:blipFill>
-          <a:blip r:embed="rId4"/>
-          <a:stretch>
-            <a:fillRect/>
-          </a:stretch>
-        </p:blipFill>
-        <p:spPr>
-          <a:xfrm>
-            <a:off x="3338368" y="3976947"/>
-            <a:ext cx="4076700" cy="1143000"/>
-          </a:xfrm>
-          <a:prstGeom prst="rect">
-            <a:avLst/>
-          </a:prstGeom>
-        </p:spPr>
-      </p:pic>
-      <p:sp>
-        <p:nvSpPr>
-          <p:cNvPr id="9" name="TextBox 8">
-            <a:extLst>
-              <a:ext uri="{FF2B5EF4-FFF2-40B4-BE49-F238E27FC236}">
-                <a16:creationId xmlns:a16="http://schemas.microsoft.com/office/drawing/2014/main" id="{0EFFDC46-7F17-E590-61C6-8FDAF6A4F1E5}"/>
-              </a:ext>
-            </a:extLst>
-          </p:cNvPr>
-          <p:cNvSpPr txBox="1"/>
-          <p:nvPr/>
-        </p:nvSpPr>
-        <p:spPr>
-          <a:xfrm>
-            <a:off x="7607877" y="6080067"/>
-            <a:ext cx="4461478" cy="646331"/>
-          </a:xfrm>
-          <a:prstGeom prst="rect">
-            <a:avLst/>
-          </a:prstGeom>
-          <a:noFill/>
-        </p:spPr>
-        <p:txBody>
-          <a:bodyPr wrap="none" rtlCol="0">
-            <a:spAutoFit/>
-          </a:bodyPr>
-          <a:lstStyle/>
-          <a:p>
-            <a:r>
-              <a:rPr lang="en-US" dirty="0"/>
-              <a:t>Jean Morrison, UMSPH</a:t>
-            </a:r>
-          </a:p>
-          <a:p>
-            <a:r>
-              <a:rPr lang="en-US" dirty="0"/>
-              <a:t>https://jean997.github.io/cause/</a:t>
-            </a:r>
-            <a:r>
-              <a:rPr lang="en-US" dirty="0" err="1"/>
-              <a:t>index.html</a:t>
-            </a:r>
-            <a:endParaRPr lang="en-US" dirty="0"/>
-          </a:p>
-        </p:txBody>
-      </p:sp>
-      <p:sp>
-        <p:nvSpPr>
-          <p:cNvPr id="10" name="TextBox 9">
-            <a:extLst>
-              <a:ext uri="{FF2B5EF4-FFF2-40B4-BE49-F238E27FC236}">
-                <a16:creationId xmlns:a16="http://schemas.microsoft.com/office/drawing/2014/main" id="{EFE66127-B2D9-3C89-103B-8EEFD22145D1}"/>
-              </a:ext>
-            </a:extLst>
-          </p:cNvPr>
-          <p:cNvSpPr txBox="1"/>
-          <p:nvPr/>
-        </p:nvSpPr>
-        <p:spPr>
-          <a:xfrm>
-            <a:off x="2697480" y="3429000"/>
-            <a:ext cx="1495987" cy="646331"/>
-          </a:xfrm>
-          <a:prstGeom prst="rect">
-            <a:avLst/>
-          </a:prstGeom>
-          <a:noFill/>
-        </p:spPr>
-        <p:txBody>
-          <a:bodyPr wrap="none" rtlCol="0">
-            <a:spAutoFit/>
-          </a:bodyPr>
-          <a:lstStyle/>
-          <a:p>
-            <a:r>
-              <a:rPr lang="en-US" dirty="0"/>
-              <a:t>Uncorrelated</a:t>
-            </a:r>
-          </a:p>
-          <a:p>
-            <a:r>
-              <a:rPr lang="en-US" dirty="0"/>
-              <a:t>Pleiotropy</a:t>
-            </a:r>
-          </a:p>
-        </p:txBody>
-      </p:sp>
-      <p:sp>
-        <p:nvSpPr>
-          <p:cNvPr id="11" name="AutoShape 4" descr="Fig. 1">
-            <a:extLst>
-              <a:ext uri="{FF2B5EF4-FFF2-40B4-BE49-F238E27FC236}">
-                <a16:creationId xmlns:a16="http://schemas.microsoft.com/office/drawing/2014/main" id="{65A43320-5EB4-86F1-CBE2-F43CD4DC8EAC}"/>
-              </a:ext>
-            </a:extLst>
-          </p:cNvPr>
-          <p:cNvSpPr>
-            <a:spLocks noChangeAspect="1" noChangeArrowheads="1"/>
-          </p:cNvSpPr>
-          <p:nvPr/>
-        </p:nvSpPr>
-        <p:spPr bwMode="auto">
-          <a:xfrm>
-            <a:off x="5943600" y="3276600"/>
-            <a:ext cx="304800" cy="304800"/>
-          </a:xfrm>
-          <a:prstGeom prst="rect">
-            <a:avLst/>
-          </a:prstGeom>
-          <a:noFill/>
-          <a:extLst>
-            <a:ext uri="{909E8E84-426E-40DD-AFC4-6F175D3DCCD1}">
-              <a14:hiddenFill xmlns:a14="http://schemas.microsoft.com/office/drawing/2010/main">
-                <a:solidFill>
-                  <a:srgbClr val="FFFFFF"/>
-                </a:solidFill>
-              </a14:hiddenFill>
-            </a:ext>
-          </a:extLst>
-        </p:spPr>
-        <p:txBody>
-          <a:bodyPr vert="horz" wrap="square" lIns="91440" tIns="45720" rIns="91440" bIns="45720" numCol="1" anchor="t" anchorCtr="0" compatLnSpc="1">
-            <a:prstTxWarp prst="textNoShape">
-              <a:avLst/>
-            </a:prstTxWarp>
-          </a:bodyPr>
-          <a:lstStyle/>
-          <a:p>
-            <a:endParaRPr lang="en-US"/>
-          </a:p>
-        </p:txBody>
-      </p:sp>
-      <p:sp>
-        <p:nvSpPr>
-          <p:cNvPr id="12" name="TextBox 11">
-            <a:extLst>
-              <a:ext uri="{FF2B5EF4-FFF2-40B4-BE49-F238E27FC236}">
-                <a16:creationId xmlns:a16="http://schemas.microsoft.com/office/drawing/2014/main" id="{69FAE68B-5197-847B-B7B4-B78BF01347A0}"/>
-              </a:ext>
-            </a:extLst>
-          </p:cNvPr>
-          <p:cNvSpPr txBox="1"/>
-          <p:nvPr/>
-        </p:nvSpPr>
-        <p:spPr>
-          <a:xfrm>
-            <a:off x="4997673" y="1444300"/>
-            <a:ext cx="1250727" cy="646331"/>
-          </a:xfrm>
-          <a:prstGeom prst="rect">
-            <a:avLst/>
-          </a:prstGeom>
-          <a:noFill/>
-        </p:spPr>
-        <p:txBody>
-          <a:bodyPr wrap="none" rtlCol="0">
-            <a:spAutoFit/>
-          </a:bodyPr>
-          <a:lstStyle/>
-          <a:p>
-            <a:r>
-              <a:rPr lang="en-US" dirty="0"/>
-              <a:t>Correlated</a:t>
-            </a:r>
-          </a:p>
-          <a:p>
-            <a:r>
-              <a:rPr lang="en-US" dirty="0"/>
-              <a:t>Pleiotropy</a:t>
-            </a:r>
-          </a:p>
-        </p:txBody>
-      </p:sp>
-      <p:sp>
-        <p:nvSpPr>
-          <p:cNvPr id="13" name="AutoShape 4" descr="Fig. 1">
-            <a:extLst>
-              <a:ext uri="{FF2B5EF4-FFF2-40B4-BE49-F238E27FC236}">
-                <a16:creationId xmlns:a16="http://schemas.microsoft.com/office/drawing/2014/main" id="{B38D2661-F47F-281D-81DE-A81562A7B0CA}"/>
-              </a:ext>
-            </a:extLst>
-          </p:cNvPr>
-          <p:cNvSpPr>
-            <a:spLocks noChangeAspect="1" noChangeArrowheads="1"/>
-          </p:cNvSpPr>
-          <p:nvPr/>
-        </p:nvSpPr>
-        <p:spPr bwMode="auto">
-          <a:xfrm>
-            <a:off x="7998533" y="1280729"/>
-            <a:ext cx="304800" cy="304800"/>
-          </a:xfrm>
-          <a:prstGeom prst="rect">
-            <a:avLst/>
-          </a:prstGeom>
-          <a:noFill/>
-          <a:extLst>
-            <a:ext uri="{909E8E84-426E-40DD-AFC4-6F175D3DCCD1}">
-              <a14:hiddenFill xmlns:a14="http://schemas.microsoft.com/office/drawing/2010/main">
-                <a:solidFill>
-                  <a:srgbClr val="FFFFFF"/>
-                </a:solidFill>
-              </a14:hiddenFill>
-            </a:ext>
-          </a:extLst>
-        </p:spPr>
-        <p:txBody>
-          <a:bodyPr vert="horz" wrap="square" lIns="91440" tIns="45720" rIns="91440" bIns="45720" numCol="1" anchor="t" anchorCtr="0" compatLnSpc="1">
-            <a:prstTxWarp prst="textNoShape">
-              <a:avLst/>
-            </a:prstTxWarp>
-          </a:bodyPr>
-          <a:lstStyle/>
-          <a:p>
-            <a:endParaRPr lang="en-US"/>
+              <a:t>Statistical Methods</a:t>
+            </a:r>
+          </a:p>
+        </p:txBody>
+      </p:sp>
+      <p:sp>
+        <p:nvSpPr>
+          <p:cNvPr id="3" name="Content Placeholder 2">
+            <a:extLst>
+              <a:ext uri="{FF2B5EF4-FFF2-40B4-BE49-F238E27FC236}">
+                <a16:creationId xmlns:a16="http://schemas.microsoft.com/office/drawing/2014/main" id="{B23B23B4-4D45-3F44-B0B9-2C7CCC779C96}"/>
+              </a:ext>
+            </a:extLst>
+          </p:cNvPr>
+          <p:cNvSpPr>
+            <a:spLocks noGrp="1"/>
+          </p:cNvSpPr>
+          <p:nvPr>
+            <p:ph idx="1"/>
+          </p:nvPr>
+        </p:nvSpPr>
+        <p:spPr/>
+        <p:txBody>
+          <a:bodyPr/>
+          <a:lstStyle/>
+          <a:p>
+            <a:r>
+              <a:rPr lang="en-US" dirty="0"/>
+              <a:t>Primary method</a:t>
+            </a:r>
+          </a:p>
+          <a:p>
+            <a:pPr lvl="1"/>
+            <a:r>
+              <a:rPr lang="en-US" dirty="0"/>
+              <a:t>Inverse Variance Weighted Multiplicative Random Effects (IVW-MRE)</a:t>
+            </a:r>
+          </a:p>
+          <a:p>
+            <a:r>
+              <a:rPr lang="en-US" dirty="0"/>
+              <a:t>Alternate methods</a:t>
+            </a:r>
+          </a:p>
+          <a:p>
+            <a:pPr lvl="1"/>
+            <a:r>
+              <a:rPr lang="en-US" dirty="0"/>
+              <a:t>MR-IVW Fixed Effects (SNPs have same error)</a:t>
+            </a:r>
+          </a:p>
+          <a:p>
+            <a:pPr lvl="1"/>
+            <a:r>
+              <a:rPr lang="en-US" dirty="0"/>
+              <a:t>MR-RAPS (SNPs have weak effect)</a:t>
+            </a:r>
+          </a:p>
+          <a:p>
+            <a:pPr lvl="1"/>
+            <a:r>
+              <a:rPr lang="en-US" dirty="0"/>
+              <a:t>Weighted median (assumes only half SNPs are valid)</a:t>
+            </a:r>
+          </a:p>
+          <a:p>
+            <a:pPr lvl="1"/>
+            <a:r>
+              <a:rPr lang="en-US" dirty="0"/>
+              <a:t>Weighted mode (plurality of SNPs have same valid effect)</a:t>
+            </a:r>
+          </a:p>
+          <a:p>
+            <a:pPr lvl="1"/>
+            <a:r>
+              <a:rPr lang="en-US" dirty="0"/>
+              <a:t>MR-Egger (assumes uncorrelated pleiotropy)</a:t>
+            </a:r>
+          </a:p>
+          <a:p>
+            <a:pPr lvl="1"/>
+            <a:r>
+              <a:rPr lang="en-US" dirty="0"/>
+              <a:t>MR-PRESSO (models for uncorrelated horizontal pleiotropy)</a:t>
+            </a:r>
+          </a:p>
+          <a:p>
+            <a:pPr lvl="1"/>
+            <a:r>
+              <a:rPr lang="en-US" dirty="0"/>
+              <a:t>MR-CAUSE (models both correlated and uncorrelated pleiotropy)</a:t>
+            </a:r>
           </a:p>
         </p:txBody>
       </p:sp>
     </p:spTree>
     <p:extLst>
       <p:ext uri="{BB962C8B-B14F-4D97-AF65-F5344CB8AC3E}">
-        <p14:creationId xmlns:p14="http://schemas.microsoft.com/office/powerpoint/2010/main" val="2097844736"/>
+        <p14:creationId xmlns:p14="http://schemas.microsoft.com/office/powerpoint/2010/main" val="309167524"/>
       </p:ext>
     </p:extLst>
   </p:cSld>
@@ -5425,7 +5592,7 @@
           <p:cNvPr id="2" name="Title 1">
             <a:extLst>
               <a:ext uri="{FF2B5EF4-FFF2-40B4-BE49-F238E27FC236}">
-                <a16:creationId xmlns:a16="http://schemas.microsoft.com/office/drawing/2014/main" id="{8E2AD01A-BFE7-08A1-5A84-CDA86F4E6C6F}"/>
+                <a16:creationId xmlns:a16="http://schemas.microsoft.com/office/drawing/2014/main" id="{8975FF7A-9BEB-B8E3-AFBC-62B955BBCEDE}"/>
               </a:ext>
             </a:extLst>
           </p:cNvPr>
@@ -5443,25 +5610,54 @@
           <a:p>
             <a:r>
               <a:rPr lang="en-US" dirty="0"/>
-              <a:t>Biological Mechanism</a:t>
-            </a:r>
-          </a:p>
-        </p:txBody>
-      </p:sp>
-      <p:sp>
-        <p:nvSpPr>
-          <p:cNvPr id="3" name="Content Placeholder 2">
-            <a:extLst>
-              <a:ext uri="{FF2B5EF4-FFF2-40B4-BE49-F238E27FC236}">
-                <a16:creationId xmlns:a16="http://schemas.microsoft.com/office/drawing/2014/main" id="{CD5056C1-AD05-EF4E-7430-CC03222639A8}"/>
-              </a:ext>
-            </a:extLst>
-          </p:cNvPr>
-          <p:cNvSpPr>
-            <a:spLocks noGrp="1"/>
-          </p:cNvSpPr>
-          <p:nvPr>
-            <p:ph idx="1"/>
+              <a:t>Series of Tests for Those Assumptions</a:t>
+            </a:r>
+          </a:p>
+        </p:txBody>
+      </p:sp>
+      <p:pic>
+        <p:nvPicPr>
+          <p:cNvPr id="8" name="Content Placeholder 7">
+            <a:extLst>
+              <a:ext uri="{FF2B5EF4-FFF2-40B4-BE49-F238E27FC236}">
+                <a16:creationId xmlns:a16="http://schemas.microsoft.com/office/drawing/2014/main" id="{6E7FE670-99E5-3E65-69A7-111450B90368}"/>
+              </a:ext>
+            </a:extLst>
+          </p:cNvPr>
+          <p:cNvPicPr>
+            <a:picLocks noGrp="1" noChangeAspect="1"/>
+          </p:cNvPicPr>
+          <p:nvPr>
+            <p:ph sz="half" idx="1"/>
+          </p:nvPr>
+        </p:nvPicPr>
+        <p:blipFill>
+          <a:blip r:embed="rId2"/>
+          <a:stretch>
+            <a:fillRect/>
+          </a:stretch>
+        </p:blipFill>
+        <p:spPr>
+          <a:xfrm>
+            <a:off x="838200" y="2150723"/>
+            <a:ext cx="5181600" cy="3701142"/>
+          </a:xfrm>
+        </p:spPr>
+      </p:pic>
+      <p:sp>
+        <p:nvSpPr>
+          <p:cNvPr id="4" name="Content Placeholder 3">
+            <a:extLst>
+              <a:ext uri="{FF2B5EF4-FFF2-40B4-BE49-F238E27FC236}">
+                <a16:creationId xmlns:a16="http://schemas.microsoft.com/office/drawing/2014/main" id="{45A4650B-083B-4BE5-4395-1FB883B8D563}"/>
+              </a:ext>
+            </a:extLst>
+          </p:cNvPr>
+          <p:cNvSpPr>
+            <a:spLocks noGrp="1"/>
+          </p:cNvSpPr>
+          <p:nvPr>
+            <p:ph sz="half" idx="2"/>
           </p:nvPr>
         </p:nvSpPr>
         <p:spPr/>
@@ -5469,14 +5665,102 @@
           <a:bodyPr/>
           <a:lstStyle/>
           <a:p>
-            <a:endParaRPr lang="en-US"/>
+            <a:r>
+              <a:rPr lang="en-US" dirty="0"/>
+              <a:t>Instruments F&gt;10</a:t>
+            </a:r>
+          </a:p>
+          <a:p>
+            <a:pPr lvl="1"/>
+            <a:r>
+              <a:rPr lang="en-US" dirty="0"/>
+              <a:t>If not use MR-RAPS</a:t>
+            </a:r>
+          </a:p>
+          <a:p>
+            <a:r>
+              <a:rPr lang="en-US" dirty="0"/>
+              <a:t>Significant heterogeneity</a:t>
+            </a:r>
+          </a:p>
+          <a:p>
+            <a:pPr lvl="1"/>
+            <a:r>
+              <a:rPr lang="en-US" dirty="0"/>
+              <a:t>Used IVW-MRE not FE</a:t>
+            </a:r>
+          </a:p>
+          <a:p>
+            <a:r>
+              <a:rPr lang="en-US" dirty="0"/>
+              <a:t>Global tests (detects outliers)</a:t>
+            </a:r>
+          </a:p>
+          <a:p>
+            <a:pPr lvl="1"/>
+            <a:r>
+              <a:rPr lang="en-US" dirty="0"/>
+              <a:t>If significant – outliers detected</a:t>
+            </a:r>
+          </a:p>
+          <a:p>
+            <a:pPr lvl="1"/>
+            <a:r>
+              <a:rPr lang="en-US" dirty="0"/>
+              <a:t>Perform a distortion test</a:t>
+            </a:r>
+          </a:p>
+          <a:p>
+            <a:pPr lvl="2"/>
+            <a:r>
+              <a:rPr lang="en-US" dirty="0"/>
+              <a:t>Adjusts for outliers (MR-PRESSO)</a:t>
+            </a:r>
+          </a:p>
+          <a:p>
+            <a:endParaRPr lang="en-US" dirty="0"/>
+          </a:p>
+        </p:txBody>
+      </p:sp>
+      <p:sp>
+        <p:nvSpPr>
+          <p:cNvPr id="9" name="TextBox 8">
+            <a:extLst>
+              <a:ext uri="{FF2B5EF4-FFF2-40B4-BE49-F238E27FC236}">
+                <a16:creationId xmlns:a16="http://schemas.microsoft.com/office/drawing/2014/main" id="{FE644AC6-171B-2C4B-609E-3208FA39C3FC}"/>
+              </a:ext>
+            </a:extLst>
+          </p:cNvPr>
+          <p:cNvSpPr txBox="1"/>
+          <p:nvPr/>
+        </p:nvSpPr>
+        <p:spPr>
+          <a:xfrm>
+            <a:off x="1898073" y="1690688"/>
+            <a:ext cx="3685309" cy="369332"/>
+          </a:xfrm>
+          <a:prstGeom prst="rect">
+            <a:avLst/>
+          </a:prstGeom>
+          <a:noFill/>
+        </p:spPr>
+        <p:txBody>
+          <a:bodyPr wrap="square" rtlCol="0">
+            <a:spAutoFit/>
+          </a:bodyPr>
+          <a:lstStyle/>
+          <a:p>
+            <a:r>
+              <a:rPr lang="en-US" dirty="0"/>
+              <a:t>Calcium-Calcium Positive Control</a:t>
+            </a:r>
           </a:p>
         </p:txBody>
       </p:sp>
     </p:spTree>
     <p:extLst>
       <p:ext uri="{BB962C8B-B14F-4D97-AF65-F5344CB8AC3E}">
-        <p14:creationId xmlns:p14="http://schemas.microsoft.com/office/powerpoint/2010/main" val="1597897761"/>
+        <p14:creationId xmlns:p14="http://schemas.microsoft.com/office/powerpoint/2010/main" val="573618394"/>
       </p:ext>
     </p:extLst>
   </p:cSld>
@@ -5508,7 +5792,7 @@
           <p:cNvPr id="2" name="Title 1">
             <a:extLst>
               <a:ext uri="{FF2B5EF4-FFF2-40B4-BE49-F238E27FC236}">
-                <a16:creationId xmlns:a16="http://schemas.microsoft.com/office/drawing/2014/main" id="{30EE970E-2DFC-8F1D-0EC2-759D88FE01E9}"/>
+                <a16:creationId xmlns:a16="http://schemas.microsoft.com/office/drawing/2014/main" id="{0806D77C-EEA2-111D-5778-C7C0C738C7EB}"/>
               </a:ext>
             </a:extLst>
           </p:cNvPr>
@@ -5526,94 +5810,44 @@
           <a:p>
             <a:r>
               <a:rPr lang="en-US" dirty="0"/>
-              <a:t>Relevance of co-</a:t>
-            </a:r>
-            <a:r>
-              <a:rPr lang="en-US" dirty="0" err="1"/>
-              <a:t>rmorbid</a:t>
-            </a:r>
-            <a:r>
-              <a:rPr lang="en-US" dirty="0"/>
-              <a:t> increases </a:t>
-            </a:r>
-          </a:p>
-        </p:txBody>
-      </p:sp>
-      <p:sp>
-        <p:nvSpPr>
-          <p:cNvPr id="3" name="Content Placeholder 2">
-            <a:extLst>
-              <a:ext uri="{FF2B5EF4-FFF2-40B4-BE49-F238E27FC236}">
-                <a16:creationId xmlns:a16="http://schemas.microsoft.com/office/drawing/2014/main" id="{D73DACDE-A2BA-5912-6E35-544C23AF9F7D}"/>
-              </a:ext>
-            </a:extLst>
-          </p:cNvPr>
-          <p:cNvSpPr>
-            <a:spLocks noGrp="1"/>
-          </p:cNvSpPr>
+              <a:t>Models Testing the Association Between Cholesterol and Calcium</a:t>
+            </a:r>
+          </a:p>
+        </p:txBody>
+      </p:sp>
+      <p:pic>
+        <p:nvPicPr>
+          <p:cNvPr id="7" name="Content Placeholder 6">
+            <a:extLst>
+              <a:ext uri="{FF2B5EF4-FFF2-40B4-BE49-F238E27FC236}">
+                <a16:creationId xmlns:a16="http://schemas.microsoft.com/office/drawing/2014/main" id="{81D12783-BD4A-92C5-84A4-AEF706F75661}"/>
+              </a:ext>
+            </a:extLst>
+          </p:cNvPr>
+          <p:cNvPicPr>
+            <a:picLocks noGrp="1" noChangeAspect="1"/>
+          </p:cNvPicPr>
           <p:nvPr>
             <p:ph idx="1"/>
           </p:nvPr>
-        </p:nvSpPr>
-        <p:spPr/>
-        <p:txBody>
-          <a:bodyPr/>
-          <a:lstStyle/>
-          <a:p>
-            <a:r>
-              <a:rPr lang="en-US" dirty="0"/>
-              <a:t>Individuals with osteoporosis have a &gt; 4 fold increased risk of myocardial infarction, and a &gt; 3.5x increased risk of stroke</a:t>
-            </a:r>
-            <a:r>
-              <a:rPr lang="en-US" i="1" dirty="0"/>
-              <a:t> (</a:t>
-            </a:r>
-            <a:r>
-              <a:rPr lang="en-US" i="1" dirty="0" err="1"/>
-              <a:t>Renjithlal</a:t>
-            </a:r>
-            <a:r>
-              <a:rPr lang="en-US" i="1" dirty="0"/>
-              <a:t> et al., 2022).</a:t>
-            </a:r>
-          </a:p>
-          <a:p>
-            <a:r>
-              <a:rPr lang="en-US" dirty="0"/>
-              <a:t>Elevated serum calcium was associated with increased risk of both arterial calcification and coronary artery disease (</a:t>
-            </a:r>
-            <a:r>
-              <a:rPr lang="en-US" i="1" dirty="0"/>
-              <a:t>Jorde et. al., 1999, Foley et. al., 2008</a:t>
-            </a:r>
-            <a:r>
-              <a:rPr lang="en-US" dirty="0"/>
-              <a:t>) .</a:t>
-            </a:r>
-          </a:p>
-          <a:p>
-            <a:r>
-              <a:rPr lang="en-US" dirty="0"/>
-              <a:t>MR shows genetically encoded calcium increases risk of CAD or myocardial infarction by 24-25% (Larssen </a:t>
-            </a:r>
-            <a:r>
-              <a:rPr lang="en-US" i="1" dirty="0"/>
-              <a:t>et. al., </a:t>
-            </a:r>
-            <a:r>
-              <a:rPr lang="en-US" dirty="0"/>
-              <a:t>2017).</a:t>
-            </a:r>
-          </a:p>
-          <a:p>
-            <a:endParaRPr lang="en-US" dirty="0"/>
-          </a:p>
-        </p:txBody>
-      </p:sp>
+        </p:nvPicPr>
+        <p:blipFill>
+          <a:blip r:embed="rId2"/>
+          <a:stretch>
+            <a:fillRect/>
+          </a:stretch>
+        </p:blipFill>
+        <p:spPr>
+          <a:xfrm>
+            <a:off x="3050063" y="1825625"/>
+            <a:ext cx="6091873" cy="4351338"/>
+          </a:xfrm>
+        </p:spPr>
+      </p:pic>
     </p:spTree>
     <p:extLst>
       <p:ext uri="{BB962C8B-B14F-4D97-AF65-F5344CB8AC3E}">
-        <p14:creationId xmlns:p14="http://schemas.microsoft.com/office/powerpoint/2010/main" val="3542917399"/>
+        <p14:creationId xmlns:p14="http://schemas.microsoft.com/office/powerpoint/2010/main" val="2418771319"/>
       </p:ext>
     </p:extLst>
   </p:cSld>
@@ -5900,6 +6134,1162 @@
     <p:extLst>
       <p:ext uri="{BB962C8B-B14F-4D97-AF65-F5344CB8AC3E}">
         <p14:creationId xmlns:p14="http://schemas.microsoft.com/office/powerpoint/2010/main" val="410721933"/>
+      </p:ext>
+    </p:extLst>
+  </p:cSld>
+  <p:clrMapOvr>
+    <a:masterClrMapping/>
+  </p:clrMapOvr>
+</p:sld>
+</file>
+
+<file path=ppt/slides/slide20.xml><?xml version="1.0" encoding="utf-8"?>
+<p:sld xmlns:a="http://schemas.openxmlformats.org/drawingml/2006/main" xmlns:r="http://schemas.openxmlformats.org/officeDocument/2006/relationships" xmlns:p="http://schemas.openxmlformats.org/presentationml/2006/main">
+  <p:cSld>
+    <p:spTree>
+      <p:nvGrpSpPr>
+        <p:cNvPr id="1" name=""/>
+        <p:cNvGrpSpPr/>
+        <p:nvPr/>
+      </p:nvGrpSpPr>
+      <p:grpSpPr>
+        <a:xfrm>
+          <a:off x="0" y="0"/>
+          <a:ext cx="0" cy="0"/>
+          <a:chOff x="0" y="0"/>
+          <a:chExt cx="0" cy="0"/>
+        </a:xfrm>
+      </p:grpSpPr>
+      <p:sp>
+        <p:nvSpPr>
+          <p:cNvPr id="2" name="Title 1">
+            <a:extLst>
+              <a:ext uri="{FF2B5EF4-FFF2-40B4-BE49-F238E27FC236}">
+                <a16:creationId xmlns:a16="http://schemas.microsoft.com/office/drawing/2014/main" id="{B1DA6101-FB1A-3FF8-719B-0B750B7B7516}"/>
+              </a:ext>
+            </a:extLst>
+          </p:cNvPr>
+          <p:cNvSpPr>
+            <a:spLocks noGrp="1"/>
+          </p:cNvSpPr>
+          <p:nvPr>
+            <p:ph type="title"/>
+          </p:nvPr>
+        </p:nvSpPr>
+        <p:spPr/>
+        <p:txBody>
+          <a:bodyPr/>
+          <a:lstStyle/>
+          <a:p>
+            <a:r>
+              <a:rPr lang="en-US" dirty="0"/>
+              <a:t>SNP Level Associations for TC-Calcium</a:t>
+            </a:r>
+          </a:p>
+        </p:txBody>
+      </p:sp>
+      <p:pic>
+        <p:nvPicPr>
+          <p:cNvPr id="5" name="Content Placeholder 4">
+            <a:extLst>
+              <a:ext uri="{FF2B5EF4-FFF2-40B4-BE49-F238E27FC236}">
+                <a16:creationId xmlns:a16="http://schemas.microsoft.com/office/drawing/2014/main" id="{42834B48-7C3A-3EA1-264D-C873889DA346}"/>
+              </a:ext>
+            </a:extLst>
+          </p:cNvPr>
+          <p:cNvPicPr>
+            <a:picLocks noGrp="1" noChangeAspect="1"/>
+          </p:cNvPicPr>
+          <p:nvPr>
+            <p:ph idx="1"/>
+          </p:nvPr>
+        </p:nvPicPr>
+        <p:blipFill>
+          <a:blip r:embed="rId2"/>
+          <a:stretch>
+            <a:fillRect/>
+          </a:stretch>
+        </p:blipFill>
+        <p:spPr>
+          <a:xfrm>
+            <a:off x="3050063" y="1825625"/>
+            <a:ext cx="6091873" cy="4351338"/>
+          </a:xfrm>
+        </p:spPr>
+      </p:pic>
+      <p:sp>
+        <p:nvSpPr>
+          <p:cNvPr id="6" name="TextBox 5">
+            <a:extLst>
+              <a:ext uri="{FF2B5EF4-FFF2-40B4-BE49-F238E27FC236}">
+                <a16:creationId xmlns:a16="http://schemas.microsoft.com/office/drawing/2014/main" id="{9F3AEA37-6869-B471-0EFC-039F33A2745B}"/>
+              </a:ext>
+            </a:extLst>
+          </p:cNvPr>
+          <p:cNvSpPr txBox="1"/>
+          <p:nvPr/>
+        </p:nvSpPr>
+        <p:spPr>
+          <a:xfrm>
+            <a:off x="4900613" y="6176963"/>
+            <a:ext cx="3454215" cy="369332"/>
+          </a:xfrm>
+          <a:prstGeom prst="rect">
+            <a:avLst/>
+          </a:prstGeom>
+          <a:noFill/>
+        </p:spPr>
+        <p:txBody>
+          <a:bodyPr wrap="none" rtlCol="0">
+            <a:spAutoFit/>
+          </a:bodyPr>
+          <a:lstStyle/>
+          <a:p>
+            <a:r>
+              <a:rPr lang="en-US" dirty="0"/>
+              <a:t>Genetically Encoded Cholesterol</a:t>
+            </a:r>
+          </a:p>
+        </p:txBody>
+      </p:sp>
+      <p:sp>
+        <p:nvSpPr>
+          <p:cNvPr id="7" name="TextBox 6">
+            <a:extLst>
+              <a:ext uri="{FF2B5EF4-FFF2-40B4-BE49-F238E27FC236}">
+                <a16:creationId xmlns:a16="http://schemas.microsoft.com/office/drawing/2014/main" id="{9F746FD5-C530-18BC-BA39-D318968CE6CE}"/>
+              </a:ext>
+            </a:extLst>
+          </p:cNvPr>
+          <p:cNvSpPr txBox="1"/>
+          <p:nvPr/>
+        </p:nvSpPr>
+        <p:spPr>
+          <a:xfrm rot="16200000">
+            <a:off x="2350673" y="3759059"/>
+            <a:ext cx="1029449" cy="369332"/>
+          </a:xfrm>
+          <a:prstGeom prst="rect">
+            <a:avLst/>
+          </a:prstGeom>
+          <a:noFill/>
+        </p:spPr>
+        <p:txBody>
+          <a:bodyPr wrap="none" rtlCol="0">
+            <a:spAutoFit/>
+          </a:bodyPr>
+          <a:lstStyle/>
+          <a:p>
+            <a:r>
+              <a:rPr lang="en-US" dirty="0"/>
+              <a:t>Calcium</a:t>
+            </a:r>
+          </a:p>
+        </p:txBody>
+      </p:sp>
+    </p:spTree>
+    <p:extLst>
+      <p:ext uri="{BB962C8B-B14F-4D97-AF65-F5344CB8AC3E}">
+        <p14:creationId xmlns:p14="http://schemas.microsoft.com/office/powerpoint/2010/main" val="2396153761"/>
+      </p:ext>
+    </p:extLst>
+  </p:cSld>
+  <p:clrMapOvr>
+    <a:masterClrMapping/>
+  </p:clrMapOvr>
+</p:sld>
+</file>
+
+<file path=ppt/slides/slide21.xml><?xml version="1.0" encoding="utf-8"?>
+<p:sld xmlns:a="http://schemas.openxmlformats.org/drawingml/2006/main" xmlns:r="http://schemas.openxmlformats.org/officeDocument/2006/relationships" xmlns:p="http://schemas.openxmlformats.org/presentationml/2006/main">
+  <p:cSld>
+    <p:spTree>
+      <p:nvGrpSpPr>
+        <p:cNvPr id="1" name=""/>
+        <p:cNvGrpSpPr/>
+        <p:nvPr/>
+      </p:nvGrpSpPr>
+      <p:grpSpPr>
+        <a:xfrm>
+          <a:off x="0" y="0"/>
+          <a:ext cx="0" cy="0"/>
+          <a:chOff x="0" y="0"/>
+          <a:chExt cx="0" cy="0"/>
+        </a:xfrm>
+      </p:grpSpPr>
+      <p:sp>
+        <p:nvSpPr>
+          <p:cNvPr id="2" name="Title 1">
+            <a:extLst>
+              <a:ext uri="{FF2B5EF4-FFF2-40B4-BE49-F238E27FC236}">
+                <a16:creationId xmlns:a16="http://schemas.microsoft.com/office/drawing/2014/main" id="{9E5C739B-7AE5-D2AE-6CF3-818BDFB256FA}"/>
+              </a:ext>
+            </a:extLst>
+          </p:cNvPr>
+          <p:cNvSpPr>
+            <a:spLocks noGrp="1"/>
+          </p:cNvSpPr>
+          <p:nvPr>
+            <p:ph type="title"/>
+          </p:nvPr>
+        </p:nvSpPr>
+        <p:spPr/>
+        <p:txBody>
+          <a:bodyPr/>
+          <a:lstStyle/>
+          <a:p>
+            <a:r>
+              <a:rPr lang="en-US" dirty="0"/>
+              <a:t>Validation Tests for Chol -&gt; Calcium</a:t>
+            </a:r>
+          </a:p>
+        </p:txBody>
+      </p:sp>
+      <p:pic>
+        <p:nvPicPr>
+          <p:cNvPr id="7" name="Content Placeholder 6">
+            <a:extLst>
+              <a:ext uri="{FF2B5EF4-FFF2-40B4-BE49-F238E27FC236}">
+                <a16:creationId xmlns:a16="http://schemas.microsoft.com/office/drawing/2014/main" id="{615F201A-0171-2328-896F-2FC930FC5345}"/>
+              </a:ext>
+            </a:extLst>
+          </p:cNvPr>
+          <p:cNvPicPr>
+            <a:picLocks noGrp="1" noChangeAspect="1"/>
+          </p:cNvPicPr>
+          <p:nvPr>
+            <p:ph sz="half" idx="1"/>
+          </p:nvPr>
+        </p:nvPicPr>
+        <p:blipFill>
+          <a:blip r:embed="rId2"/>
+          <a:stretch>
+            <a:fillRect/>
+          </a:stretch>
+        </p:blipFill>
+        <p:spPr>
+          <a:xfrm>
+            <a:off x="838200" y="2150723"/>
+            <a:ext cx="5181600" cy="3701142"/>
+          </a:xfrm>
+        </p:spPr>
+      </p:pic>
+      <p:pic>
+        <p:nvPicPr>
+          <p:cNvPr id="9" name="Content Placeholder 8">
+            <a:extLst>
+              <a:ext uri="{FF2B5EF4-FFF2-40B4-BE49-F238E27FC236}">
+                <a16:creationId xmlns:a16="http://schemas.microsoft.com/office/drawing/2014/main" id="{D5ACF8AC-A57B-48CD-D44F-E4D615031BD7}"/>
+              </a:ext>
+            </a:extLst>
+          </p:cNvPr>
+          <p:cNvPicPr>
+            <a:picLocks noGrp="1" noChangeAspect="1"/>
+          </p:cNvPicPr>
+          <p:nvPr>
+            <p:ph sz="half" idx="2"/>
+          </p:nvPr>
+        </p:nvPicPr>
+        <p:blipFill>
+          <a:blip r:embed="rId3"/>
+          <a:stretch>
+            <a:fillRect/>
+          </a:stretch>
+        </p:blipFill>
+        <p:spPr>
+          <a:xfrm>
+            <a:off x="6172200" y="2150723"/>
+            <a:ext cx="5181600" cy="3701142"/>
+          </a:xfrm>
+        </p:spPr>
+      </p:pic>
+    </p:spTree>
+    <p:extLst>
+      <p:ext uri="{BB962C8B-B14F-4D97-AF65-F5344CB8AC3E}">
+        <p14:creationId xmlns:p14="http://schemas.microsoft.com/office/powerpoint/2010/main" val="3850254958"/>
+      </p:ext>
+    </p:extLst>
+  </p:cSld>
+  <p:clrMapOvr>
+    <a:masterClrMapping/>
+  </p:clrMapOvr>
+  <p:timing>
+    <p:tnLst>
+      <p:par>
+        <p:cTn id="1" dur="indefinite" restart="never" nodeType="tmRoot">
+          <p:childTnLst>
+            <p:seq concurrent="1" nextAc="seek">
+              <p:cTn id="2" dur="indefinite" nodeType="mainSeq">
+                <p:childTnLst>
+                  <p:par>
+                    <p:cTn id="3" fill="hold">
+                      <p:stCondLst>
+                        <p:cond delay="indefinite"/>
+                      </p:stCondLst>
+                      <p:childTnLst>
+                        <p:par>
+                          <p:cTn id="4" fill="hold">
+                            <p:stCondLst>
+                              <p:cond delay="0"/>
+                            </p:stCondLst>
+                            <p:childTnLst>
+                              <p:par>
+                                <p:cTn id="5" presetID="3" presetClass="entr" presetSubtype="10" fill="hold" nodeType="clickEffect">
+                                  <p:stCondLst>
+                                    <p:cond delay="0"/>
+                                  </p:stCondLst>
+                                  <p:childTnLst>
+                                    <p:set>
+                                      <p:cBhvr>
+                                        <p:cTn id="6" dur="1" fill="hold">
+                                          <p:stCondLst>
+                                            <p:cond delay="0"/>
+                                          </p:stCondLst>
+                                        </p:cTn>
+                                        <p:tgtEl>
+                                          <p:spTgt spid="9"/>
+                                        </p:tgtEl>
+                                        <p:attrNameLst>
+                                          <p:attrName>style.visibility</p:attrName>
+                                        </p:attrNameLst>
+                                      </p:cBhvr>
+                                      <p:to>
+                                        <p:strVal val="visible"/>
+                                      </p:to>
+                                    </p:set>
+                                    <p:animEffect transition="in" filter="blinds(horizontal)">
+                                      <p:cBhvr>
+                                        <p:cTn id="7" dur="500"/>
+                                        <p:tgtEl>
+                                          <p:spTgt spid="9"/>
+                                        </p:tgtEl>
+                                      </p:cBhvr>
+                                    </p:animEffect>
+                                  </p:childTnLst>
+                                </p:cTn>
+                              </p:par>
+                            </p:childTnLst>
+                          </p:cTn>
+                        </p:par>
+                      </p:childTnLst>
+                    </p:cTn>
+                  </p:par>
+                </p:childTnLst>
+              </p:cTn>
+              <p:prevCondLst>
+                <p:cond evt="onPrev" delay="0">
+                  <p:tgtEl>
+                    <p:sldTgt/>
+                  </p:tgtEl>
+                </p:cond>
+              </p:prevCondLst>
+              <p:nextCondLst>
+                <p:cond evt="onNext" delay="0">
+                  <p:tgtEl>
+                    <p:sldTgt/>
+                  </p:tgtEl>
+                </p:cond>
+              </p:nextCondLst>
+            </p:seq>
+          </p:childTnLst>
+        </p:cTn>
+      </p:par>
+    </p:tnLst>
+  </p:timing>
+</p:sld>
+</file>
+
+<file path=ppt/slides/slide22.xml><?xml version="1.0" encoding="utf-8"?>
+<p:sld xmlns:a="http://schemas.openxmlformats.org/drawingml/2006/main" xmlns:r="http://schemas.openxmlformats.org/officeDocument/2006/relationships" xmlns:p="http://schemas.openxmlformats.org/presentationml/2006/main">
+  <p:cSld>
+    <p:spTree>
+      <p:nvGrpSpPr>
+        <p:cNvPr id="1" name=""/>
+        <p:cNvGrpSpPr/>
+        <p:nvPr/>
+      </p:nvGrpSpPr>
+      <p:grpSpPr>
+        <a:xfrm>
+          <a:off x="0" y="0"/>
+          <a:ext cx="0" cy="0"/>
+          <a:chOff x="0" y="0"/>
+          <a:chExt cx="0" cy="0"/>
+        </a:xfrm>
+      </p:grpSpPr>
+      <p:sp>
+        <p:nvSpPr>
+          <p:cNvPr id="2" name="Title 1">
+            <a:extLst>
+              <a:ext uri="{FF2B5EF4-FFF2-40B4-BE49-F238E27FC236}">
+                <a16:creationId xmlns:a16="http://schemas.microsoft.com/office/drawing/2014/main" id="{C91A23B5-01D2-030E-F22A-F2F00E1A5D77}"/>
+              </a:ext>
+            </a:extLst>
+          </p:cNvPr>
+          <p:cNvSpPr>
+            <a:spLocks noGrp="1"/>
+          </p:cNvSpPr>
+          <p:nvPr>
+            <p:ph type="title"/>
+          </p:nvPr>
+        </p:nvSpPr>
+        <p:spPr/>
+        <p:txBody>
+          <a:bodyPr/>
+          <a:lstStyle/>
+          <a:p>
+            <a:r>
+              <a:rPr lang="en-US" dirty="0"/>
+              <a:t>Overall Results</a:t>
+            </a:r>
+          </a:p>
+        </p:txBody>
+      </p:sp>
+      <p:pic>
+        <p:nvPicPr>
+          <p:cNvPr id="10" name="Content Placeholder 9">
+            <a:extLst>
+              <a:ext uri="{FF2B5EF4-FFF2-40B4-BE49-F238E27FC236}">
+                <a16:creationId xmlns:a16="http://schemas.microsoft.com/office/drawing/2014/main" id="{C049725B-73B6-03C9-1553-E0DCEF7D6363}"/>
+              </a:ext>
+            </a:extLst>
+          </p:cNvPr>
+          <p:cNvPicPr>
+            <a:picLocks noGrp="1" noChangeAspect="1"/>
+          </p:cNvPicPr>
+          <p:nvPr>
+            <p:ph idx="1"/>
+          </p:nvPr>
+        </p:nvPicPr>
+        <p:blipFill>
+          <a:blip r:embed="rId2"/>
+          <a:stretch>
+            <a:fillRect/>
+          </a:stretch>
+        </p:blipFill>
+        <p:spPr>
+          <a:xfrm>
+            <a:off x="3050063" y="1825625"/>
+            <a:ext cx="6091873" cy="4351338"/>
+          </a:xfrm>
+        </p:spPr>
+      </p:pic>
+    </p:spTree>
+    <p:extLst>
+      <p:ext uri="{BB962C8B-B14F-4D97-AF65-F5344CB8AC3E}">
+        <p14:creationId xmlns:p14="http://schemas.microsoft.com/office/powerpoint/2010/main" val="1252783467"/>
+      </p:ext>
+    </p:extLst>
+  </p:cSld>
+  <p:clrMapOvr>
+    <a:masterClrMapping/>
+  </p:clrMapOvr>
+</p:sld>
+</file>
+
+<file path=ppt/slides/slide23.xml><?xml version="1.0" encoding="utf-8"?>
+<p:sld xmlns:a="http://schemas.openxmlformats.org/drawingml/2006/main" xmlns:r="http://schemas.openxmlformats.org/officeDocument/2006/relationships" xmlns:p="http://schemas.openxmlformats.org/presentationml/2006/main">
+  <p:cSld>
+    <p:spTree>
+      <p:nvGrpSpPr>
+        <p:cNvPr id="1" name=""/>
+        <p:cNvGrpSpPr/>
+        <p:nvPr/>
+      </p:nvGrpSpPr>
+      <p:grpSpPr>
+        <a:xfrm>
+          <a:off x="0" y="0"/>
+          <a:ext cx="0" cy="0"/>
+          <a:chOff x="0" y="0"/>
+          <a:chExt cx="0" cy="0"/>
+        </a:xfrm>
+      </p:grpSpPr>
+      <p:sp>
+        <p:nvSpPr>
+          <p:cNvPr id="2" name="Title 1">
+            <a:extLst>
+              <a:ext uri="{FF2B5EF4-FFF2-40B4-BE49-F238E27FC236}">
+                <a16:creationId xmlns:a16="http://schemas.microsoft.com/office/drawing/2014/main" id="{8E2AD01A-BFE7-08A1-5A84-CDA86F4E6C6F}"/>
+              </a:ext>
+            </a:extLst>
+          </p:cNvPr>
+          <p:cNvSpPr>
+            <a:spLocks noGrp="1"/>
+          </p:cNvSpPr>
+          <p:nvPr>
+            <p:ph type="title"/>
+          </p:nvPr>
+        </p:nvSpPr>
+        <p:spPr/>
+        <p:txBody>
+          <a:bodyPr/>
+          <a:lstStyle/>
+          <a:p>
+            <a:r>
+              <a:rPr lang="en-US" dirty="0"/>
+              <a:t>Possible Biological Mechanism</a:t>
+            </a:r>
+          </a:p>
+        </p:txBody>
+      </p:sp>
+      <p:sp>
+        <p:nvSpPr>
+          <p:cNvPr id="3" name="Content Placeholder 2">
+            <a:extLst>
+              <a:ext uri="{FF2B5EF4-FFF2-40B4-BE49-F238E27FC236}">
+                <a16:creationId xmlns:a16="http://schemas.microsoft.com/office/drawing/2014/main" id="{CD5056C1-AD05-EF4E-7430-CC03222639A8}"/>
+              </a:ext>
+            </a:extLst>
+          </p:cNvPr>
+          <p:cNvSpPr>
+            <a:spLocks noGrp="1"/>
+          </p:cNvSpPr>
+          <p:nvPr>
+            <p:ph idx="1"/>
+          </p:nvPr>
+        </p:nvSpPr>
+        <p:spPr/>
+        <p:txBody>
+          <a:bodyPr/>
+          <a:lstStyle/>
+          <a:p>
+            <a:r>
+              <a:rPr lang="en-US" dirty="0"/>
+              <a:t>H1: Cholesterol -&gt; High Vitamin D </a:t>
+            </a:r>
+            <a:r>
+              <a:rPr lang="en-US" dirty="0">
+                <a:sym typeface="Wingdings" pitchFamily="2" charset="2"/>
+              </a:rPr>
+              <a:t> More Ca</a:t>
+            </a:r>
+          </a:p>
+          <a:p>
+            <a:r>
+              <a:rPr lang="en-US" dirty="0">
+                <a:sym typeface="Wingdings" pitchFamily="2" charset="2"/>
+              </a:rPr>
+              <a:t>H2: Cholesterol -&gt; Bone demineralization -&gt; More Ca	</a:t>
+            </a:r>
+          </a:p>
+          <a:p>
+            <a:endParaRPr lang="en-US" dirty="0">
+              <a:sym typeface="Wingdings" pitchFamily="2" charset="2"/>
+            </a:endParaRPr>
+          </a:p>
+          <a:p>
+            <a:r>
+              <a:rPr lang="en-US" dirty="0">
+                <a:sym typeface="Wingdings" pitchFamily="2" charset="2"/>
+              </a:rPr>
+              <a:t>Exposure</a:t>
+            </a:r>
+          </a:p>
+          <a:p>
+            <a:pPr lvl="1"/>
+            <a:r>
+              <a:rPr lang="en-US" dirty="0">
+                <a:sym typeface="Wingdings" pitchFamily="2" charset="2"/>
+              </a:rPr>
+              <a:t>Total Cholesterol SNPS from UK </a:t>
+            </a:r>
+            <a:r>
+              <a:rPr lang="en-US" dirty="0" err="1">
+                <a:sym typeface="Wingdings" pitchFamily="2" charset="2"/>
+              </a:rPr>
+              <a:t>BioBanl</a:t>
+            </a:r>
+            <a:endParaRPr lang="en-US" dirty="0">
+              <a:sym typeface="Wingdings" pitchFamily="2" charset="2"/>
+            </a:endParaRPr>
+          </a:p>
+          <a:p>
+            <a:r>
+              <a:rPr lang="en-US" dirty="0">
+                <a:sym typeface="Wingdings" pitchFamily="2" charset="2"/>
+              </a:rPr>
+              <a:t>Outcomes</a:t>
+            </a:r>
+          </a:p>
+          <a:p>
+            <a:pPr lvl="1"/>
+            <a:r>
+              <a:rPr lang="en-US" dirty="0">
+                <a:sym typeface="Wingdings" pitchFamily="2" charset="2"/>
+              </a:rPr>
+              <a:t>Vitamin D levels (MGI-</a:t>
+            </a:r>
+            <a:r>
+              <a:rPr lang="en-US" dirty="0" err="1">
+                <a:sym typeface="Wingdings" pitchFamily="2" charset="2"/>
+              </a:rPr>
+              <a:t>BioVU</a:t>
+            </a:r>
+            <a:r>
+              <a:rPr lang="en-US" dirty="0">
+                <a:sym typeface="Wingdings" pitchFamily="2" charset="2"/>
+              </a:rPr>
+              <a:t> </a:t>
+            </a:r>
+            <a:r>
+              <a:rPr lang="en-US" dirty="0" err="1">
+                <a:sym typeface="Wingdings" pitchFamily="2" charset="2"/>
+              </a:rPr>
+              <a:t>LabWAS</a:t>
+            </a:r>
+            <a:r>
+              <a:rPr lang="en-US" dirty="0">
+                <a:sym typeface="Wingdings" pitchFamily="2" charset="2"/>
+              </a:rPr>
+              <a:t>)</a:t>
+            </a:r>
+          </a:p>
+          <a:p>
+            <a:pPr lvl="1"/>
+            <a:r>
+              <a:rPr lang="en-US" dirty="0">
+                <a:sym typeface="Wingdings" pitchFamily="2" charset="2"/>
+              </a:rPr>
+              <a:t>Bone mineral density (GEFOS)</a:t>
+            </a:r>
+          </a:p>
+        </p:txBody>
+      </p:sp>
+    </p:spTree>
+    <p:extLst>
+      <p:ext uri="{BB962C8B-B14F-4D97-AF65-F5344CB8AC3E}">
+        <p14:creationId xmlns:p14="http://schemas.microsoft.com/office/powerpoint/2010/main" val="1597897761"/>
+      </p:ext>
+    </p:extLst>
+  </p:cSld>
+  <p:clrMapOvr>
+    <a:masterClrMapping/>
+  </p:clrMapOvr>
+</p:sld>
+</file>
+
+<file path=ppt/slides/slide24.xml><?xml version="1.0" encoding="utf-8"?>
+<p:sld xmlns:a="http://schemas.openxmlformats.org/drawingml/2006/main" xmlns:r="http://schemas.openxmlformats.org/officeDocument/2006/relationships" xmlns:p="http://schemas.openxmlformats.org/presentationml/2006/main">
+  <p:cSld>
+    <p:spTree>
+      <p:nvGrpSpPr>
+        <p:cNvPr id="1" name=""/>
+        <p:cNvGrpSpPr/>
+        <p:nvPr/>
+      </p:nvGrpSpPr>
+      <p:grpSpPr>
+        <a:xfrm>
+          <a:off x="0" y="0"/>
+          <a:ext cx="0" cy="0"/>
+          <a:chOff x="0" y="0"/>
+          <a:chExt cx="0" cy="0"/>
+        </a:xfrm>
+      </p:grpSpPr>
+      <p:sp>
+        <p:nvSpPr>
+          <p:cNvPr id="2" name="Title 1">
+            <a:extLst>
+              <a:ext uri="{FF2B5EF4-FFF2-40B4-BE49-F238E27FC236}">
+                <a16:creationId xmlns:a16="http://schemas.microsoft.com/office/drawing/2014/main" id="{8FF98434-5FD8-89B6-50FC-5E402619950F}"/>
+              </a:ext>
+            </a:extLst>
+          </p:cNvPr>
+          <p:cNvSpPr>
+            <a:spLocks noGrp="1"/>
+          </p:cNvSpPr>
+          <p:nvPr>
+            <p:ph type="title"/>
+          </p:nvPr>
+        </p:nvSpPr>
+        <p:spPr/>
+        <p:txBody>
+          <a:bodyPr/>
+          <a:lstStyle/>
+          <a:p>
+            <a:r>
+              <a:rPr lang="en-US" dirty="0"/>
+              <a:t>Results</a:t>
+            </a:r>
+          </a:p>
+        </p:txBody>
+      </p:sp>
+      <p:pic>
+        <p:nvPicPr>
+          <p:cNvPr id="7" name="Content Placeholder 6">
+            <a:extLst>
+              <a:ext uri="{FF2B5EF4-FFF2-40B4-BE49-F238E27FC236}">
+                <a16:creationId xmlns:a16="http://schemas.microsoft.com/office/drawing/2014/main" id="{C610CA4F-59A7-C530-7F9F-D683B4954549}"/>
+              </a:ext>
+            </a:extLst>
+          </p:cNvPr>
+          <p:cNvPicPr>
+            <a:picLocks noGrp="1" noChangeAspect="1"/>
+          </p:cNvPicPr>
+          <p:nvPr>
+            <p:ph sz="half" idx="1"/>
+          </p:nvPr>
+        </p:nvPicPr>
+        <p:blipFill>
+          <a:blip r:embed="rId2"/>
+          <a:stretch>
+            <a:fillRect/>
+          </a:stretch>
+        </p:blipFill>
+        <p:spPr>
+          <a:xfrm>
+            <a:off x="838200" y="2150723"/>
+            <a:ext cx="5181600" cy="3701142"/>
+          </a:xfrm>
+        </p:spPr>
+      </p:pic>
+      <p:sp>
+        <p:nvSpPr>
+          <p:cNvPr id="5" name="Content Placeholder 4">
+            <a:extLst>
+              <a:ext uri="{FF2B5EF4-FFF2-40B4-BE49-F238E27FC236}">
+                <a16:creationId xmlns:a16="http://schemas.microsoft.com/office/drawing/2014/main" id="{11FE1E24-0CA5-1293-F63A-505EF0BC96DE}"/>
+              </a:ext>
+            </a:extLst>
+          </p:cNvPr>
+          <p:cNvSpPr>
+            <a:spLocks noGrp="1"/>
+          </p:cNvSpPr>
+          <p:nvPr>
+            <p:ph sz="half" idx="2"/>
+          </p:nvPr>
+        </p:nvSpPr>
+        <p:spPr/>
+        <p:txBody>
+          <a:bodyPr/>
+          <a:lstStyle/>
+          <a:p>
+            <a:r>
+              <a:rPr lang="en-US" dirty="0"/>
+              <a:t>Bayesian Inference</a:t>
+            </a:r>
+          </a:p>
+          <a:p>
+            <a:r>
+              <a:rPr lang="en-US" dirty="0"/>
+              <a:t>Probability of hypothesis true</a:t>
+            </a:r>
+          </a:p>
+          <a:p>
+            <a:pPr lvl="1"/>
+            <a:r>
+              <a:rPr lang="en-US" dirty="0"/>
+              <a:t>Vit D True = 2.5%</a:t>
+            </a:r>
+          </a:p>
+          <a:p>
+            <a:pPr lvl="1"/>
+            <a:r>
+              <a:rPr lang="en-US" dirty="0"/>
+              <a:t>BMD True = 88.8%</a:t>
+            </a:r>
+          </a:p>
+          <a:p>
+            <a:pPr lvl="1"/>
+            <a:r>
+              <a:rPr lang="en-US" dirty="0"/>
+              <a:t>Both True = 8.5%</a:t>
+            </a:r>
+          </a:p>
+          <a:p>
+            <a:pPr lvl="1"/>
+            <a:r>
+              <a:rPr lang="en-US" dirty="0"/>
+              <a:t>Neither True = 0.2%</a:t>
+            </a:r>
+          </a:p>
+        </p:txBody>
+      </p:sp>
+    </p:spTree>
+    <p:extLst>
+      <p:ext uri="{BB962C8B-B14F-4D97-AF65-F5344CB8AC3E}">
+        <p14:creationId xmlns:p14="http://schemas.microsoft.com/office/powerpoint/2010/main" val="3942614710"/>
+      </p:ext>
+    </p:extLst>
+  </p:cSld>
+  <p:clrMapOvr>
+    <a:masterClrMapping/>
+  </p:clrMapOvr>
+</p:sld>
+</file>
+
+<file path=ppt/slides/slide25.xml><?xml version="1.0" encoding="utf-8"?>
+<p:sld xmlns:a="http://schemas.openxmlformats.org/drawingml/2006/main" xmlns:r="http://schemas.openxmlformats.org/officeDocument/2006/relationships" xmlns:p="http://schemas.openxmlformats.org/presentationml/2006/main">
+  <p:cSld>
+    <p:spTree>
+      <p:nvGrpSpPr>
+        <p:cNvPr id="1" name=""/>
+        <p:cNvGrpSpPr/>
+        <p:nvPr/>
+      </p:nvGrpSpPr>
+      <p:grpSpPr>
+        <a:xfrm>
+          <a:off x="0" y="0"/>
+          <a:ext cx="0" cy="0"/>
+          <a:chOff x="0" y="0"/>
+          <a:chExt cx="0" cy="0"/>
+        </a:xfrm>
+      </p:grpSpPr>
+      <p:sp>
+        <p:nvSpPr>
+          <p:cNvPr id="2" name="Title 1">
+            <a:extLst>
+              <a:ext uri="{FF2B5EF4-FFF2-40B4-BE49-F238E27FC236}">
+                <a16:creationId xmlns:a16="http://schemas.microsoft.com/office/drawing/2014/main" id="{30EE970E-2DFC-8F1D-0EC2-759D88FE01E9}"/>
+              </a:ext>
+            </a:extLst>
+          </p:cNvPr>
+          <p:cNvSpPr>
+            <a:spLocks noGrp="1"/>
+          </p:cNvSpPr>
+          <p:nvPr>
+            <p:ph type="title"/>
+          </p:nvPr>
+        </p:nvSpPr>
+        <p:spPr/>
+        <p:txBody>
+          <a:bodyPr/>
+          <a:lstStyle/>
+          <a:p>
+            <a:r>
+              <a:rPr lang="en-US" dirty="0"/>
+              <a:t>Relevance of co-morbid increases </a:t>
+            </a:r>
+          </a:p>
+        </p:txBody>
+      </p:sp>
+      <p:sp>
+        <p:nvSpPr>
+          <p:cNvPr id="3" name="Content Placeholder 2">
+            <a:extLst>
+              <a:ext uri="{FF2B5EF4-FFF2-40B4-BE49-F238E27FC236}">
+                <a16:creationId xmlns:a16="http://schemas.microsoft.com/office/drawing/2014/main" id="{D73DACDE-A2BA-5912-6E35-544C23AF9F7D}"/>
+              </a:ext>
+            </a:extLst>
+          </p:cNvPr>
+          <p:cNvSpPr>
+            <a:spLocks noGrp="1"/>
+          </p:cNvSpPr>
+          <p:nvPr>
+            <p:ph idx="1"/>
+          </p:nvPr>
+        </p:nvSpPr>
+        <p:spPr/>
+        <p:txBody>
+          <a:bodyPr/>
+          <a:lstStyle/>
+          <a:p>
+            <a:r>
+              <a:rPr lang="en-US" dirty="0"/>
+              <a:t>Individuals with osteoporosis have a &gt; 4 fold increased risk of myocardial infarction, and a &gt; 3.5x increased risk of stroke</a:t>
+            </a:r>
+            <a:r>
+              <a:rPr lang="en-US" i="1" dirty="0"/>
+              <a:t> (</a:t>
+            </a:r>
+            <a:r>
+              <a:rPr lang="en-US" i="1" dirty="0" err="1"/>
+              <a:t>Renjithlal</a:t>
+            </a:r>
+            <a:r>
+              <a:rPr lang="en-US" i="1" dirty="0"/>
+              <a:t> et al., 2022).</a:t>
+            </a:r>
+          </a:p>
+          <a:p>
+            <a:r>
+              <a:rPr lang="en-US" dirty="0"/>
+              <a:t>Elevated serum calcium was associated with increased risk of both myocardial infarction and coronary artery disease (</a:t>
+            </a:r>
+            <a:r>
+              <a:rPr lang="en-US" i="1" dirty="0"/>
+              <a:t>Jorde et. al., 1999, Foley et. al., 2008</a:t>
+            </a:r>
+            <a:r>
+              <a:rPr lang="en-US" dirty="0"/>
+              <a:t>) .</a:t>
+            </a:r>
+          </a:p>
+          <a:p>
+            <a:r>
+              <a:rPr lang="en-US" dirty="0"/>
+              <a:t>MR shows genetically encoded calcium increases risk of CAD or myocardial infarction by 24-25% per SD (Larssen </a:t>
+            </a:r>
+            <a:r>
+              <a:rPr lang="en-US" i="1" dirty="0"/>
+              <a:t>et. al., </a:t>
+            </a:r>
+            <a:r>
+              <a:rPr lang="en-US" dirty="0"/>
+              <a:t>2017).</a:t>
+            </a:r>
+          </a:p>
+          <a:p>
+            <a:endParaRPr lang="en-US" dirty="0"/>
+          </a:p>
+        </p:txBody>
+      </p:sp>
+    </p:spTree>
+    <p:extLst>
+      <p:ext uri="{BB962C8B-B14F-4D97-AF65-F5344CB8AC3E}">
+        <p14:creationId xmlns:p14="http://schemas.microsoft.com/office/powerpoint/2010/main" val="3542917399"/>
+      </p:ext>
+    </p:extLst>
+  </p:cSld>
+  <p:clrMapOvr>
+    <a:masterClrMapping/>
+  </p:clrMapOvr>
+</p:sld>
+</file>
+
+<file path=ppt/slides/slide26.xml><?xml version="1.0" encoding="utf-8"?>
+<p:sld xmlns:a="http://schemas.openxmlformats.org/drawingml/2006/main" xmlns:r="http://schemas.openxmlformats.org/officeDocument/2006/relationships" xmlns:p="http://schemas.openxmlformats.org/presentationml/2006/main">
+  <p:cSld>
+    <p:spTree>
+      <p:nvGrpSpPr>
+        <p:cNvPr id="1" name=""/>
+        <p:cNvGrpSpPr/>
+        <p:nvPr/>
+      </p:nvGrpSpPr>
+      <p:grpSpPr>
+        <a:xfrm>
+          <a:off x="0" y="0"/>
+          <a:ext cx="0" cy="0"/>
+          <a:chOff x="0" y="0"/>
+          <a:chExt cx="0" cy="0"/>
+        </a:xfrm>
+      </p:grpSpPr>
+      <p:sp>
+        <p:nvSpPr>
+          <p:cNvPr id="2" name="Title 1">
+            <a:extLst>
+              <a:ext uri="{FF2B5EF4-FFF2-40B4-BE49-F238E27FC236}">
+                <a16:creationId xmlns:a16="http://schemas.microsoft.com/office/drawing/2014/main" id="{F96A7BB2-6B11-15E3-B839-DBD022A04D82}"/>
+              </a:ext>
+            </a:extLst>
+          </p:cNvPr>
+          <p:cNvSpPr>
+            <a:spLocks noGrp="1"/>
+          </p:cNvSpPr>
+          <p:nvPr>
+            <p:ph type="title"/>
+          </p:nvPr>
+        </p:nvSpPr>
+        <p:spPr/>
+        <p:txBody>
+          <a:bodyPr/>
+          <a:lstStyle/>
+          <a:p>
+            <a:r>
+              <a:rPr lang="en-US" dirty="0"/>
+              <a:t>Design</a:t>
+            </a:r>
+          </a:p>
+        </p:txBody>
+      </p:sp>
+      <p:sp>
+        <p:nvSpPr>
+          <p:cNvPr id="3" name="Content Placeholder 2">
+            <a:extLst>
+              <a:ext uri="{FF2B5EF4-FFF2-40B4-BE49-F238E27FC236}">
+                <a16:creationId xmlns:a16="http://schemas.microsoft.com/office/drawing/2014/main" id="{EE7009FD-1057-B476-A2C5-9FC8AB425FEE}"/>
+              </a:ext>
+            </a:extLst>
+          </p:cNvPr>
+          <p:cNvSpPr>
+            <a:spLocks noGrp="1"/>
+          </p:cNvSpPr>
+          <p:nvPr>
+            <p:ph sz="half" idx="1"/>
+          </p:nvPr>
+        </p:nvSpPr>
+        <p:spPr/>
+        <p:txBody>
+          <a:bodyPr/>
+          <a:lstStyle/>
+          <a:p>
+            <a:r>
+              <a:rPr lang="en-US" dirty="0"/>
+              <a:t>Mice</a:t>
+            </a:r>
+          </a:p>
+          <a:p>
+            <a:pPr lvl="1"/>
+            <a:r>
+              <a:rPr lang="en-US" dirty="0"/>
+              <a:t>Models</a:t>
+            </a:r>
+          </a:p>
+          <a:p>
+            <a:pPr lvl="2"/>
+            <a:r>
+              <a:rPr lang="en-US" dirty="0"/>
+              <a:t>WT</a:t>
+            </a:r>
+          </a:p>
+          <a:p>
+            <a:pPr lvl="2"/>
+            <a:r>
+              <a:rPr lang="en-US" dirty="0"/>
+              <a:t>PTH</a:t>
+            </a:r>
+          </a:p>
+          <a:p>
+            <a:pPr lvl="2"/>
+            <a:r>
+              <a:rPr lang="en-US" dirty="0"/>
+              <a:t>LDR knockout</a:t>
+            </a:r>
+          </a:p>
+          <a:p>
+            <a:pPr lvl="2"/>
+            <a:r>
+              <a:rPr lang="en-US" dirty="0"/>
+              <a:t>PTH + LDLR knockout</a:t>
+            </a:r>
+          </a:p>
+          <a:p>
+            <a:pPr lvl="1"/>
+            <a:r>
+              <a:rPr lang="en-US" dirty="0"/>
+              <a:t>Outcomes</a:t>
+            </a:r>
+          </a:p>
+          <a:p>
+            <a:pPr lvl="2"/>
+            <a:r>
+              <a:rPr lang="en-US" dirty="0"/>
+              <a:t>Atherosclerotic plaques</a:t>
+            </a:r>
+          </a:p>
+          <a:p>
+            <a:pPr lvl="2"/>
+            <a:r>
+              <a:rPr lang="en-US" dirty="0"/>
+              <a:t>Memory?</a:t>
+            </a:r>
+          </a:p>
+          <a:p>
+            <a:pPr lvl="1"/>
+            <a:endParaRPr lang="en-US" dirty="0"/>
+          </a:p>
+        </p:txBody>
+      </p:sp>
+      <p:sp>
+        <p:nvSpPr>
+          <p:cNvPr id="4" name="Content Placeholder 3">
+            <a:extLst>
+              <a:ext uri="{FF2B5EF4-FFF2-40B4-BE49-F238E27FC236}">
+                <a16:creationId xmlns:a16="http://schemas.microsoft.com/office/drawing/2014/main" id="{8A413F27-14D4-D176-2B40-4E7655BB75B4}"/>
+              </a:ext>
+            </a:extLst>
+          </p:cNvPr>
+          <p:cNvSpPr>
+            <a:spLocks noGrp="1"/>
+          </p:cNvSpPr>
+          <p:nvPr>
+            <p:ph sz="half" idx="2"/>
+          </p:nvPr>
+        </p:nvSpPr>
+        <p:spPr/>
+        <p:txBody>
+          <a:bodyPr/>
+          <a:lstStyle/>
+          <a:p>
+            <a:r>
+              <a:rPr lang="en-US" dirty="0"/>
+              <a:t>Humans</a:t>
+            </a:r>
+          </a:p>
+          <a:p>
+            <a:pPr lvl="1"/>
+            <a:r>
+              <a:rPr lang="en-US" dirty="0"/>
+              <a:t>Longitudinal analysis </a:t>
+            </a:r>
+          </a:p>
+          <a:p>
+            <a:pPr lvl="2"/>
+            <a:r>
+              <a:rPr lang="en-US" dirty="0"/>
+              <a:t>Exposures</a:t>
+            </a:r>
+          </a:p>
+          <a:p>
+            <a:pPr lvl="3"/>
+            <a:r>
+              <a:rPr lang="en-US" dirty="0"/>
+              <a:t>Cholesterol/LDL-C</a:t>
+            </a:r>
+          </a:p>
+          <a:p>
+            <a:pPr lvl="3"/>
+            <a:r>
+              <a:rPr lang="en-US" dirty="0"/>
+              <a:t>Serum calcium</a:t>
+            </a:r>
+          </a:p>
+          <a:p>
+            <a:pPr lvl="2"/>
+            <a:r>
+              <a:rPr lang="en-US" dirty="0"/>
+              <a:t>Outcomes </a:t>
+            </a:r>
+          </a:p>
+          <a:p>
+            <a:pPr lvl="3"/>
+            <a:r>
+              <a:rPr lang="en-US" dirty="0"/>
+              <a:t>MACE</a:t>
+            </a:r>
+          </a:p>
+          <a:p>
+            <a:pPr lvl="2"/>
+            <a:r>
+              <a:rPr lang="en-US" dirty="0"/>
+              <a:t>Covariates</a:t>
+            </a:r>
+          </a:p>
+          <a:p>
+            <a:pPr lvl="3"/>
+            <a:r>
+              <a:rPr lang="en-US" dirty="0"/>
+              <a:t>Age</a:t>
+            </a:r>
+          </a:p>
+          <a:p>
+            <a:pPr lvl="3"/>
+            <a:r>
+              <a:rPr lang="en-US" dirty="0"/>
+              <a:t>BMI</a:t>
+            </a:r>
+          </a:p>
+          <a:p>
+            <a:pPr lvl="3"/>
+            <a:r>
+              <a:rPr lang="en-US" dirty="0"/>
+              <a:t>Diabetes</a:t>
+            </a:r>
+          </a:p>
+          <a:p>
+            <a:pPr lvl="3"/>
+            <a:r>
+              <a:rPr lang="en-US" dirty="0"/>
+              <a:t>SES</a:t>
+            </a:r>
+          </a:p>
+          <a:p>
+            <a:endParaRPr lang="en-US" dirty="0"/>
+          </a:p>
+        </p:txBody>
+      </p:sp>
+    </p:spTree>
+    <p:extLst>
+      <p:ext uri="{BB962C8B-B14F-4D97-AF65-F5344CB8AC3E}">
+        <p14:creationId xmlns:p14="http://schemas.microsoft.com/office/powerpoint/2010/main" val="1552452627"/>
       </p:ext>
     </p:extLst>
   </p:cSld>
@@ -6155,10 +7545,10 @@
       </p:sp>
       <p:pic>
         <p:nvPicPr>
-          <p:cNvPr id="5" name="Content Placeholder 4">
-            <a:extLst>
-              <a:ext uri="{FF2B5EF4-FFF2-40B4-BE49-F238E27FC236}">
-                <a16:creationId xmlns:a16="http://schemas.microsoft.com/office/drawing/2014/main" id="{805BED9D-F7BF-AA6D-84F5-CB0C18931B5D}"/>
+          <p:cNvPr id="9" name="Content Placeholder 8">
+            <a:extLst>
+              <a:ext uri="{FF2B5EF4-FFF2-40B4-BE49-F238E27FC236}">
+                <a16:creationId xmlns:a16="http://schemas.microsoft.com/office/drawing/2014/main" id="{903B8723-2DA8-038C-C0B4-4D12DE3FD27B}"/>
               </a:ext>
             </a:extLst>
           </p:cNvPr>
@@ -6171,17 +7561,59 @@
         </p:nvPicPr>
         <p:blipFill>
           <a:blip r:embed="rId2"/>
+          <a:srcRect t="15329"/>
           <a:stretch>
             <a:fillRect/>
           </a:stretch>
         </p:blipFill>
         <p:spPr>
           <a:xfrm>
-            <a:off x="3050063" y="1825625"/>
-            <a:ext cx="6091873" cy="4351338"/>
+            <a:off x="-692727" y="1312956"/>
+            <a:ext cx="10319573" cy="6241191"/>
           </a:xfrm>
         </p:spPr>
       </p:pic>
+      <p:sp>
+        <p:nvSpPr>
+          <p:cNvPr id="10" name="TextBox 9">
+            <a:extLst>
+              <a:ext uri="{FF2B5EF4-FFF2-40B4-BE49-F238E27FC236}">
+                <a16:creationId xmlns:a16="http://schemas.microsoft.com/office/drawing/2014/main" id="{6C8E003F-A6D3-EF22-F5D9-5C25ED6D6AAC}"/>
+              </a:ext>
+            </a:extLst>
+          </p:cNvPr>
+          <p:cNvSpPr txBox="1"/>
+          <p:nvPr/>
+        </p:nvSpPr>
+        <p:spPr>
+          <a:xfrm>
+            <a:off x="8504627" y="5976142"/>
+            <a:ext cx="2709140" cy="646331"/>
+          </a:xfrm>
+          <a:prstGeom prst="rect">
+            <a:avLst/>
+          </a:prstGeom>
+          <a:noFill/>
+        </p:spPr>
+        <p:txBody>
+          <a:bodyPr wrap="none" rtlCol="0">
+            <a:spAutoFit/>
+          </a:bodyPr>
+          <a:lstStyle/>
+          <a:p>
+            <a:r>
+              <a:rPr lang="en-US" dirty="0"/>
+              <a:t>Mean cholesterol (mg/dL)</a:t>
+            </a:r>
+          </a:p>
+          <a:p>
+            <a:r>
+              <a:rPr lang="en-US" dirty="0"/>
+              <a:t>Number of mice</a:t>
+            </a:r>
+          </a:p>
+        </p:txBody>
+      </p:sp>
     </p:spTree>
     <p:extLst>
       <p:ext uri="{BB962C8B-B14F-4D97-AF65-F5344CB8AC3E}">

</xml_diff>